<commit_message>
Addressing issue #40 & some edits in Fig. 1
</commit_message>
<xml_diff>
--- a/docs/figures/fig01_workflow_draft.pptx
+++ b/docs/figures/fig01_workflow_draft.pptx
@@ -1812,234 +1812,6 @@
       </p:sp>
       <p:sp>
         <p:nvSpPr>
-          <p:cNvPr id="8" name="Shape 6">
-            <a:extLst>
-              <a:ext uri="{FF2B5EF4-FFF2-40B4-BE49-F238E27FC236}">
-                <a16:creationId xmlns:a16="http://schemas.microsoft.com/office/drawing/2014/main" id="{1BD02EC4-BD80-9920-2237-14B4D8AFC162}"/>
-              </a:ext>
-            </a:extLst>
-          </p:cNvPr>
-          <p:cNvSpPr/>
-          <p:nvPr/>
-        </p:nvSpPr>
-        <p:spPr>
-          <a:xfrm>
-            <a:off x="6071616" y="1335895"/>
-            <a:ext cx="137160" cy="0"/>
-          </a:xfrm>
-          <a:prstGeom prst="line">
-            <a:avLst/>
-          </a:prstGeom>
-          <a:noFill/>
-          <a:ln w="12700">
-            <a:solidFill>
-              <a:srgbClr val="B8B3A4"/>
-            </a:solidFill>
-            <a:prstDash val="solid"/>
-            <a:headEnd type="none"/>
-            <a:tailEnd type="triangle"/>
-          </a:ln>
-        </p:spPr>
-        <p:txBody>
-          <a:bodyPr/>
-          <a:lstStyle/>
-          <a:p>
-            <a:endParaRPr lang="en-US" sz="2400"/>
-          </a:p>
-        </p:txBody>
-      </p:sp>
-      <p:sp>
-        <p:nvSpPr>
-          <p:cNvPr id="9" name="Shape 7">
-            <a:extLst>
-              <a:ext uri="{FF2B5EF4-FFF2-40B4-BE49-F238E27FC236}">
-                <a16:creationId xmlns:a16="http://schemas.microsoft.com/office/drawing/2014/main" id="{B8B26515-2345-E480-73E4-289FFA47DFCE}"/>
-              </a:ext>
-            </a:extLst>
-          </p:cNvPr>
-          <p:cNvSpPr/>
-          <p:nvPr/>
-        </p:nvSpPr>
-        <p:spPr>
-          <a:xfrm>
-            <a:off x="6071616" y="2862943"/>
-            <a:ext cx="137160" cy="0"/>
-          </a:xfrm>
-          <a:prstGeom prst="line">
-            <a:avLst/>
-          </a:prstGeom>
-          <a:noFill/>
-          <a:ln w="12700">
-            <a:solidFill>
-              <a:srgbClr val="B8B3A4"/>
-            </a:solidFill>
-            <a:prstDash val="solid"/>
-            <a:headEnd type="none"/>
-            <a:tailEnd type="triangle"/>
-          </a:ln>
-        </p:spPr>
-        <p:txBody>
-          <a:bodyPr/>
-          <a:lstStyle/>
-          <a:p>
-            <a:endParaRPr lang="en-US" sz="2400"/>
-          </a:p>
-        </p:txBody>
-      </p:sp>
-      <p:sp>
-        <p:nvSpPr>
-          <p:cNvPr id="10" name="Shape 8">
-            <a:extLst>
-              <a:ext uri="{FF2B5EF4-FFF2-40B4-BE49-F238E27FC236}">
-                <a16:creationId xmlns:a16="http://schemas.microsoft.com/office/drawing/2014/main" id="{4AAC4C84-E098-793D-65C5-082D6317AF30}"/>
-              </a:ext>
-            </a:extLst>
-          </p:cNvPr>
-          <p:cNvSpPr/>
-          <p:nvPr/>
-        </p:nvSpPr>
-        <p:spPr>
-          <a:xfrm>
-            <a:off x="6071616" y="4426567"/>
-            <a:ext cx="137160" cy="0"/>
-          </a:xfrm>
-          <a:prstGeom prst="line">
-            <a:avLst/>
-          </a:prstGeom>
-          <a:noFill/>
-          <a:ln w="12700">
-            <a:solidFill>
-              <a:srgbClr val="B8B3A4"/>
-            </a:solidFill>
-            <a:prstDash val="solid"/>
-            <a:headEnd type="none"/>
-            <a:tailEnd type="triangle"/>
-          </a:ln>
-        </p:spPr>
-        <p:txBody>
-          <a:bodyPr/>
-          <a:lstStyle/>
-          <a:p>
-            <a:endParaRPr lang="en-US" sz="2400"/>
-          </a:p>
-        </p:txBody>
-      </p:sp>
-      <p:sp>
-        <p:nvSpPr>
-          <p:cNvPr id="11" name="Shape 9">
-            <a:extLst>
-              <a:ext uri="{FF2B5EF4-FFF2-40B4-BE49-F238E27FC236}">
-                <a16:creationId xmlns:a16="http://schemas.microsoft.com/office/drawing/2014/main" id="{B7F46754-93A8-380F-72AF-0E387240DC6F}"/>
-              </a:ext>
-            </a:extLst>
-          </p:cNvPr>
-          <p:cNvSpPr/>
-          <p:nvPr/>
-        </p:nvSpPr>
-        <p:spPr>
-          <a:xfrm>
-            <a:off x="6071616" y="6380335"/>
-            <a:ext cx="137160" cy="0"/>
-          </a:xfrm>
-          <a:prstGeom prst="line">
-            <a:avLst/>
-          </a:prstGeom>
-          <a:noFill/>
-          <a:ln w="12700">
-            <a:solidFill>
-              <a:srgbClr val="B8B3A4"/>
-            </a:solidFill>
-            <a:prstDash val="solid"/>
-            <a:headEnd type="none"/>
-            <a:tailEnd type="triangle"/>
-          </a:ln>
-        </p:spPr>
-        <p:txBody>
-          <a:bodyPr/>
-          <a:lstStyle/>
-          <a:p>
-            <a:endParaRPr lang="en-US" sz="2400"/>
-          </a:p>
-        </p:txBody>
-      </p:sp>
-      <p:sp>
-        <p:nvSpPr>
-          <p:cNvPr id="12" name="Shape 10">
-            <a:extLst>
-              <a:ext uri="{FF2B5EF4-FFF2-40B4-BE49-F238E27FC236}">
-                <a16:creationId xmlns:a16="http://schemas.microsoft.com/office/drawing/2014/main" id="{B6BC9883-4386-3AE2-3E0C-E4D0B1613AAC}"/>
-              </a:ext>
-            </a:extLst>
-          </p:cNvPr>
-          <p:cNvSpPr/>
-          <p:nvPr/>
-        </p:nvSpPr>
-        <p:spPr>
-          <a:xfrm>
-            <a:off x="6071616" y="8117187"/>
-            <a:ext cx="137160" cy="0"/>
-          </a:xfrm>
-          <a:prstGeom prst="line">
-            <a:avLst/>
-          </a:prstGeom>
-          <a:noFill/>
-          <a:ln w="12700">
-            <a:solidFill>
-              <a:srgbClr val="B8B3A4"/>
-            </a:solidFill>
-            <a:prstDash val="solid"/>
-            <a:headEnd type="none"/>
-            <a:tailEnd type="triangle"/>
-          </a:ln>
-        </p:spPr>
-        <p:txBody>
-          <a:bodyPr/>
-          <a:lstStyle/>
-          <a:p>
-            <a:endParaRPr lang="en-US" sz="2400"/>
-          </a:p>
-        </p:txBody>
-      </p:sp>
-      <p:sp>
-        <p:nvSpPr>
-          <p:cNvPr id="13" name="Shape 11">
-            <a:extLst>
-              <a:ext uri="{FF2B5EF4-FFF2-40B4-BE49-F238E27FC236}">
-                <a16:creationId xmlns:a16="http://schemas.microsoft.com/office/drawing/2014/main" id="{D0D965DC-F56A-C00A-B864-2B54437CF55F}"/>
-              </a:ext>
-            </a:extLst>
-          </p:cNvPr>
-          <p:cNvSpPr/>
-          <p:nvPr/>
-        </p:nvSpPr>
-        <p:spPr>
-          <a:xfrm>
-            <a:off x="6071616" y="9542635"/>
-            <a:ext cx="137160" cy="0"/>
-          </a:xfrm>
-          <a:prstGeom prst="line">
-            <a:avLst/>
-          </a:prstGeom>
-          <a:noFill/>
-          <a:ln w="12700">
-            <a:solidFill>
-              <a:srgbClr val="B8B3A4"/>
-            </a:solidFill>
-            <a:prstDash val="solid"/>
-            <a:headEnd type="none"/>
-            <a:tailEnd type="triangle"/>
-          </a:ln>
-        </p:spPr>
-        <p:txBody>
-          <a:bodyPr/>
-          <a:lstStyle/>
-          <a:p>
-            <a:endParaRPr lang="en-US" sz="2400"/>
-          </a:p>
-        </p:txBody>
-      </p:sp>
-      <p:sp>
-        <p:nvSpPr>
           <p:cNvPr id="14" name="Shape 12">
             <a:extLst>
               <a:ext uri="{FF2B5EF4-FFF2-40B4-BE49-F238E27FC236}">
@@ -3075,7 +2847,7 @@
         </p:nvSpPr>
         <p:spPr>
           <a:xfrm>
-            <a:off x="420624" y="9244584"/>
+            <a:off x="443917" y="9207884"/>
             <a:ext cx="1133856" cy="731520"/>
           </a:xfrm>
           <a:prstGeom prst="rect">
@@ -3094,7 +2866,7 @@
               <a:buNone/>
             </a:pPr>
             <a:r>
-              <a:rPr lang="en-US" sz="1280" b="1" dirty="0">
+              <a:rPr lang="en-US" sz="1400" b="1" dirty="0">
                 <a:solidFill>
                   <a:srgbClr val="FFFFFF"/>
                 </a:solidFill>
@@ -3104,14 +2876,14 @@
               </a:rPr>
               <a:t>Dataset</a:t>
             </a:r>
-            <a:endParaRPr lang="en-US" sz="1280" dirty="0"/>
+            <a:endParaRPr lang="en-US" sz="1400" dirty="0"/>
           </a:p>
           <a:p>
             <a:pPr marL="0" indent="0" algn="ctr">
               <a:buNone/>
             </a:pPr>
             <a:r>
-              <a:rPr lang="en-US" sz="1280" b="1" dirty="0">
+              <a:rPr lang="en-US" sz="1400" b="1" dirty="0">
                 <a:solidFill>
                   <a:srgbClr val="FFFFFF"/>
                 </a:solidFill>
@@ -3121,7 +2893,7 @@
               </a:rPr>
               <a:t>development</a:t>
             </a:r>
-            <a:endParaRPr lang="en-US" sz="1280" dirty="0"/>
+            <a:endParaRPr lang="en-US" sz="1400" dirty="0"/>
           </a:p>
         </p:txBody>
       </p:sp>
@@ -3206,7 +2978,7 @@
                 <a:ea typeface="Arial" pitchFamily="34" charset="-122"/>
                 <a:cs typeface="Arial" pitchFamily="34" charset="-120"/>
               </a:rPr>
-              <a:t>Candidate P-E analysis pairs</a:t>
+              <a:t>P-E analysis pairs</a:t>
             </a:r>
             <a:endParaRPr lang="en-US" sz="1200" dirty="0"/>
           </a:p>
@@ -3253,7 +3025,7 @@
                 <a:ea typeface="Arial" pitchFamily="34" charset="-122"/>
                 <a:cs typeface="Arial" pitchFamily="34" charset="-120"/>
               </a:rPr>
-              <a:t>ERA5-Land · FLDAS · MERRA-2</a:t>
+              <a:t>ERA5-Land - FLDAS - MERRA-2</a:t>
             </a:r>
             <a:endParaRPr lang="en-US" sz="1000" dirty="0"/>
           </a:p>
@@ -3261,6 +3033,17 @@
             <a:pPr marL="0" indent="0">
               <a:buNone/>
             </a:pPr>
+            <a:r>
+              <a:rPr lang="en-US" sz="1000" dirty="0" err="1">
+                <a:solidFill>
+                  <a:srgbClr val="25322D"/>
+                </a:solidFill>
+                <a:latin typeface="Arial" pitchFamily="34" charset="0"/>
+                <a:ea typeface="Arial" pitchFamily="34" charset="-122"/>
+                <a:cs typeface="Arial" pitchFamily="34" charset="-120"/>
+              </a:rPr>
+              <a:t>TerraClimate</a:t>
+            </a:r>
             <a:r>
               <a:rPr lang="en-US" sz="1000" dirty="0">
                 <a:solidFill>
@@ -3270,7 +3053,7 @@
                 <a:ea typeface="Arial" pitchFamily="34" charset="-122"/>
                 <a:cs typeface="Arial" pitchFamily="34" charset="-120"/>
               </a:rPr>
-              <a:t>TerraClimate · GLEAM (MSWEP P + GLEAM E)</a:t>
+              <a:t> - GLEAM (MSWEP P + GLEAM E)</a:t>
             </a:r>
             <a:endParaRPr lang="en-US" sz="1000" dirty="0"/>
           </a:p>
@@ -3330,7 +3113,7 @@
         </p:nvSpPr>
         <p:spPr>
           <a:xfrm>
-            <a:off x="1847088" y="1363093"/>
+            <a:off x="1968998" y="1363093"/>
             <a:ext cx="1828800" cy="164592"/>
           </a:xfrm>
           <a:prstGeom prst="rect">
@@ -3377,7 +3160,7 @@
         </p:nvSpPr>
         <p:spPr>
           <a:xfrm>
-            <a:off x="2095594" y="1672699"/>
+            <a:off x="1837757" y="1672699"/>
             <a:ext cx="1828800" cy="246888"/>
           </a:xfrm>
           <a:prstGeom prst="rect">
@@ -3392,7 +3175,7 @@
           </a:bodyPr>
           <a:lstStyle/>
           <a:p>
-            <a:pPr marL="0" indent="0">
+            <a:pPr marL="0" indent="0" algn="ctr">
               <a:buNone/>
             </a:pPr>
             <a:r>
@@ -3409,7 +3192,7 @@
             <a:endParaRPr lang="en-US" sz="1000" dirty="0"/>
           </a:p>
           <a:p>
-            <a:pPr marL="0" indent="0">
+            <a:pPr marL="0" indent="0" algn="ctr">
               <a:buNone/>
             </a:pPr>
             <a:r>
@@ -3421,7 +3204,7 @@
                 <a:ea typeface="Arial" pitchFamily="34" charset="-122"/>
                 <a:cs typeface="Arial" pitchFamily="34" charset="-120"/>
               </a:rPr>
-              <a:t>evaluation only</a:t>
+              <a:t>for weight assessment</a:t>
             </a:r>
             <a:endParaRPr lang="en-US" sz="1000" dirty="0"/>
           </a:p>
@@ -3543,7 +3326,150 @@
           </a:bodyPr>
           <a:lstStyle/>
           <a:p>
-            <a:pPr marL="0" indent="0" algn="ctr">
+            <a:pPr algn="ctr"/>
+            <a:r>
+              <a:rPr lang="en-US" sz="1000" dirty="0">
+                <a:solidFill>
+                  <a:srgbClr val="25322D"/>
+                </a:solidFill>
+                <a:latin typeface="Arial" pitchFamily="34" charset="0"/>
+                <a:ea typeface="Arial" pitchFamily="34" charset="-122"/>
+                <a:cs typeface="Arial" pitchFamily="34" charset="-120"/>
+              </a:rPr>
+              <a:t>MERRA-2 &amp; MSWX temperature products × 6 PET methods</a:t>
+            </a:r>
+            <a:endParaRPr lang="en-US" sz="1000" dirty="0"/>
+          </a:p>
+        </p:txBody>
+      </p:sp>
+      <p:sp>
+        <p:nvSpPr>
+          <p:cNvPr id="52" name="Shape 50">
+            <a:extLst>
+              <a:ext uri="{FF2B5EF4-FFF2-40B4-BE49-F238E27FC236}">
+                <a16:creationId xmlns:a16="http://schemas.microsoft.com/office/drawing/2014/main" id="{6F699458-BE85-4BB3-B29B-1343496CE50D}"/>
+              </a:ext>
+            </a:extLst>
+          </p:cNvPr>
+          <p:cNvSpPr/>
+          <p:nvPr/>
+        </p:nvSpPr>
+        <p:spPr>
+          <a:xfrm>
+            <a:off x="1719072" y="2497226"/>
+            <a:ext cx="2011680" cy="722376"/>
+          </a:xfrm>
+          <a:prstGeom prst="roundRect">
+            <a:avLst>
+              <a:gd name="adj" fmla="val 11429"/>
+            </a:avLst>
+          </a:prstGeom>
+          <a:solidFill>
+            <a:srgbClr val="FFFFFF"/>
+          </a:solidFill>
+          <a:ln w="13335">
+            <a:solidFill>
+              <a:srgbClr val="3275A5"/>
+            </a:solidFill>
+            <a:prstDash val="solid"/>
+          </a:ln>
+        </p:spPr>
+        <p:txBody>
+          <a:bodyPr/>
+          <a:lstStyle/>
+          <a:p>
+            <a:endParaRPr lang="en-US"/>
+          </a:p>
+        </p:txBody>
+      </p:sp>
+      <p:sp>
+        <p:nvSpPr>
+          <p:cNvPr id="53" name="Text 51">
+            <a:extLst>
+              <a:ext uri="{FF2B5EF4-FFF2-40B4-BE49-F238E27FC236}">
+                <a16:creationId xmlns:a16="http://schemas.microsoft.com/office/drawing/2014/main" id="{4F57D69E-D717-F1EB-0732-F8DD47C322E1}"/>
+              </a:ext>
+            </a:extLst>
+          </p:cNvPr>
+          <p:cNvSpPr/>
+          <p:nvPr/>
+        </p:nvSpPr>
+        <p:spPr>
+          <a:xfrm>
+            <a:off x="2083712" y="2529649"/>
+            <a:ext cx="1920240" cy="164592"/>
+          </a:xfrm>
+          <a:prstGeom prst="rect">
+            <a:avLst/>
+          </a:prstGeom>
+          <a:noFill/>
+          <a:ln/>
+        </p:spPr>
+        <p:txBody>
+          <a:bodyPr wrap="square" lIns="0" tIns="0" rIns="0" bIns="0" rtlCol="0" anchor="ctr">
+            <a:noAutofit/>
+          </a:bodyPr>
+          <a:lstStyle/>
+          <a:p>
+            <a:pPr marL="0" indent="0">
+              <a:buNone/>
+            </a:pPr>
+            <a:r>
+              <a:rPr lang="en-US" sz="1200" b="1" dirty="0" err="1">
+                <a:solidFill>
+                  <a:srgbClr val="3275A5"/>
+                </a:solidFill>
+                <a:latin typeface="Arial" pitchFamily="34" charset="0"/>
+                <a:ea typeface="Arial" pitchFamily="34" charset="-122"/>
+                <a:cs typeface="Arial" pitchFamily="34" charset="-120"/>
+              </a:rPr>
+              <a:t>Harmonised</a:t>
+            </a:r>
+            <a:r>
+              <a:rPr lang="en-US" sz="1200" b="1" dirty="0">
+                <a:solidFill>
+                  <a:srgbClr val="3275A5"/>
+                </a:solidFill>
+                <a:latin typeface="Arial" pitchFamily="34" charset="0"/>
+                <a:ea typeface="Arial" pitchFamily="34" charset="-122"/>
+                <a:cs typeface="Arial" pitchFamily="34" charset="-120"/>
+              </a:rPr>
+              <a:t> grid</a:t>
+            </a:r>
+            <a:endParaRPr lang="en-US" sz="1200" dirty="0"/>
+          </a:p>
+        </p:txBody>
+      </p:sp>
+      <p:sp>
+        <p:nvSpPr>
+          <p:cNvPr id="54" name="Text 52">
+            <a:extLst>
+              <a:ext uri="{FF2B5EF4-FFF2-40B4-BE49-F238E27FC236}">
+                <a16:creationId xmlns:a16="http://schemas.microsoft.com/office/drawing/2014/main" id="{514C462E-3968-62E9-FA4B-4277777731CD}"/>
+              </a:ext>
+            </a:extLst>
+          </p:cNvPr>
+          <p:cNvSpPr/>
+          <p:nvPr/>
+        </p:nvSpPr>
+        <p:spPr>
+          <a:xfrm>
+            <a:off x="1901952" y="2774708"/>
+            <a:ext cx="1828800" cy="347106"/>
+          </a:xfrm>
+          <a:prstGeom prst="rect">
+            <a:avLst/>
+          </a:prstGeom>
+          <a:noFill/>
+          <a:ln/>
+        </p:spPr>
+        <p:txBody>
+          <a:bodyPr wrap="square" lIns="0" tIns="0" rIns="0" bIns="0" rtlCol="0" anchor="ctr">
+            <a:normAutofit/>
+          </a:bodyPr>
+          <a:lstStyle/>
+          <a:p>
+            <a:pPr marL="0" indent="0">
               <a:buNone/>
             </a:pPr>
             <a:r>
@@ -3555,179 +3481,36 @@
                 <a:ea typeface="Arial" pitchFamily="34" charset="-122"/>
                 <a:cs typeface="Arial" pitchFamily="34" charset="-120"/>
               </a:rPr>
-              <a:t>2 temperature products x 6 methods</a:t>
+              <a:t>0.25° - annual - 1982-2021 -</a:t>
             </a:r>
-            <a:endParaRPr lang="en-US" sz="1000" dirty="0"/>
           </a:p>
           <a:p>
             <a:pPr marL="0" indent="0" algn="ctr">
               <a:buNone/>
             </a:pPr>
             <a:r>
-              <a:rPr lang="en-US" sz="1000" dirty="0">
-                <a:solidFill>
-                  <a:srgbClr val="25322D"/>
-                </a:solidFill>
-                <a:latin typeface="Arial" pitchFamily="34" charset="0"/>
-                <a:ea typeface="Arial" pitchFamily="34" charset="-122"/>
-                <a:cs typeface="Arial" pitchFamily="34" charset="-120"/>
-              </a:rPr>
-              <a:t>plausibility screening</a:t>
+              <a:rPr lang="en-US" sz="1000" dirty="0"/>
+              <a:t>land only</a:t>
             </a:r>
-            <a:endParaRPr lang="en-US" sz="1000" dirty="0"/>
-          </a:p>
-        </p:txBody>
-      </p:sp>
-      <p:sp>
-        <p:nvSpPr>
-          <p:cNvPr id="48" name="Shape 46">
-            <a:extLst>
-              <a:ext uri="{FF2B5EF4-FFF2-40B4-BE49-F238E27FC236}">
-                <a16:creationId xmlns:a16="http://schemas.microsoft.com/office/drawing/2014/main" id="{B9B020BB-9A7B-4D29-C430-78B49F4ED0A8}"/>
-              </a:ext>
-            </a:extLst>
-          </p:cNvPr>
-          <p:cNvSpPr/>
-          <p:nvPr/>
-        </p:nvSpPr>
-        <p:spPr>
-          <a:xfrm>
-            <a:off x="6254496" y="960991"/>
-            <a:ext cx="1170432" cy="640080"/>
-          </a:xfrm>
-          <a:prstGeom prst="roundRect">
-            <a:avLst>
-              <a:gd name="adj" fmla="val 9756"/>
-            </a:avLst>
-          </a:prstGeom>
-          <a:solidFill>
-            <a:srgbClr val="F6F6F0"/>
-          </a:solidFill>
-          <a:ln w="12700">
-            <a:solidFill>
-              <a:srgbClr val="B8B3A4"/>
-            </a:solidFill>
-            <a:prstDash val="solid"/>
-          </a:ln>
-        </p:spPr>
-        <p:txBody>
-          <a:bodyPr/>
-          <a:lstStyle/>
-          <a:p>
-            <a:endParaRPr lang="en-US" sz="2400"/>
-          </a:p>
-        </p:txBody>
-      </p:sp>
-      <p:sp>
-        <p:nvSpPr>
-          <p:cNvPr id="50" name="Text 48">
-            <a:extLst>
-              <a:ext uri="{FF2B5EF4-FFF2-40B4-BE49-F238E27FC236}">
-                <a16:creationId xmlns:a16="http://schemas.microsoft.com/office/drawing/2014/main" id="{DF8A7D32-506C-889E-6549-4F91B370D8D4}"/>
-              </a:ext>
-            </a:extLst>
-          </p:cNvPr>
-          <p:cNvSpPr/>
-          <p:nvPr/>
-        </p:nvSpPr>
-        <p:spPr>
-          <a:xfrm>
-            <a:off x="6336792" y="1056881"/>
-            <a:ext cx="1005840" cy="164592"/>
-          </a:xfrm>
-          <a:prstGeom prst="rect">
-            <a:avLst/>
-          </a:prstGeom>
-          <a:noFill/>
-          <a:ln/>
-        </p:spPr>
-        <p:txBody>
-          <a:bodyPr wrap="square" lIns="0" tIns="0" rIns="0" bIns="0" rtlCol="0" anchor="ctr">
-            <a:normAutofit/>
-          </a:bodyPr>
-          <a:lstStyle/>
-          <a:p>
-            <a:pPr marL="0" indent="0">
-              <a:buNone/>
-            </a:pPr>
-            <a:r>
-              <a:rPr lang="en-US" sz="1050" b="1" dirty="0">
-                <a:solidFill>
-                  <a:srgbClr val="25322D"/>
-                </a:solidFill>
-                <a:latin typeface="Arial" pitchFamily="34" charset="0"/>
-                <a:ea typeface="Arial" pitchFamily="34" charset="-122"/>
-                <a:cs typeface="Arial" pitchFamily="34" charset="-120"/>
-              </a:rPr>
-              <a:t>Input inventory</a:t>
-            </a:r>
-            <a:endParaRPr lang="en-US" sz="1050" dirty="0"/>
-          </a:p>
-        </p:txBody>
-      </p:sp>
-      <p:sp>
-        <p:nvSpPr>
-          <p:cNvPr id="51" name="Text 49">
-            <a:extLst>
-              <a:ext uri="{FF2B5EF4-FFF2-40B4-BE49-F238E27FC236}">
-                <a16:creationId xmlns:a16="http://schemas.microsoft.com/office/drawing/2014/main" id="{2E6386AD-1D72-2E9F-4491-84F25A666617}"/>
-              </a:ext>
-            </a:extLst>
-          </p:cNvPr>
-          <p:cNvSpPr/>
-          <p:nvPr/>
-        </p:nvSpPr>
-        <p:spPr>
-          <a:xfrm>
-            <a:off x="6336792" y="1282390"/>
-            <a:ext cx="1005840" cy="219456"/>
-          </a:xfrm>
-          <a:prstGeom prst="rect">
-            <a:avLst/>
-          </a:prstGeom>
-          <a:noFill/>
-          <a:ln/>
-        </p:spPr>
-        <p:txBody>
-          <a:bodyPr wrap="square" lIns="0" tIns="0" rIns="0" bIns="0" rtlCol="0" anchor="ctr">
-            <a:noAutofit/>
-          </a:bodyPr>
-          <a:lstStyle/>
-          <a:p>
-            <a:pPr marL="0" indent="0">
-              <a:buNone/>
-            </a:pPr>
-            <a:r>
-              <a:rPr lang="en-US" sz="900" dirty="0">
-                <a:solidFill>
-                  <a:srgbClr val="667269"/>
-                </a:solidFill>
-                <a:latin typeface="Arial" pitchFamily="34" charset="0"/>
-                <a:ea typeface="Arial" pitchFamily="34" charset="-122"/>
-                <a:cs typeface="Arial" pitchFamily="34" charset="-120"/>
-              </a:rPr>
-              <a:t>Origin and data roles</a:t>
-            </a:r>
-            <a:endParaRPr lang="en-US" sz="900" dirty="0"/>
-          </a:p>
-        </p:txBody>
-      </p:sp>
-      <p:sp>
-        <p:nvSpPr>
-          <p:cNvPr id="52" name="Shape 50">
-            <a:extLst>
-              <a:ext uri="{FF2B5EF4-FFF2-40B4-BE49-F238E27FC236}">
-                <a16:creationId xmlns:a16="http://schemas.microsoft.com/office/drawing/2014/main" id="{6F699458-BE85-4BB3-B29B-1343496CE50D}"/>
-              </a:ext>
-            </a:extLst>
-          </p:cNvPr>
-          <p:cNvSpPr/>
-          <p:nvPr/>
-        </p:nvSpPr>
-        <p:spPr>
-          <a:xfrm>
-            <a:off x="1719072" y="2497226"/>
-            <a:ext cx="2011680" cy="722376"/>
+          </a:p>
+        </p:txBody>
+      </p:sp>
+      <p:sp>
+        <p:nvSpPr>
+          <p:cNvPr id="55" name="Shape 53">
+            <a:extLst>
+              <a:ext uri="{FF2B5EF4-FFF2-40B4-BE49-F238E27FC236}">
+                <a16:creationId xmlns:a16="http://schemas.microsoft.com/office/drawing/2014/main" id="{6E843CC2-1F2F-C3E0-D455-965A695B59AD}"/>
+              </a:ext>
+            </a:extLst>
+          </p:cNvPr>
+          <p:cNvSpPr/>
+          <p:nvPr/>
+        </p:nvSpPr>
+        <p:spPr>
+          <a:xfrm>
+            <a:off x="3895344" y="2497226"/>
+            <a:ext cx="2103120" cy="722376"/>
           </a:xfrm>
           <a:prstGeom prst="roundRect">
             <a:avLst>
@@ -3754,20 +3537,20 @@
       </p:sp>
       <p:sp>
         <p:nvSpPr>
-          <p:cNvPr id="53" name="Text 51">
-            <a:extLst>
-              <a:ext uri="{FF2B5EF4-FFF2-40B4-BE49-F238E27FC236}">
-                <a16:creationId xmlns:a16="http://schemas.microsoft.com/office/drawing/2014/main" id="{4F57D69E-D717-F1EB-0732-F8DD47C322E1}"/>
-              </a:ext>
-            </a:extLst>
-          </p:cNvPr>
-          <p:cNvSpPr/>
-          <p:nvPr/>
-        </p:nvSpPr>
-        <p:spPr>
-          <a:xfrm>
-            <a:off x="1816608" y="2500739"/>
-            <a:ext cx="1920240" cy="164592"/>
+          <p:cNvPr id="56" name="Text 54">
+            <a:extLst>
+              <a:ext uri="{FF2B5EF4-FFF2-40B4-BE49-F238E27FC236}">
+                <a16:creationId xmlns:a16="http://schemas.microsoft.com/office/drawing/2014/main" id="{443DE53F-6FF8-07AA-C26F-415FA20B11E9}"/>
+              </a:ext>
+            </a:extLst>
+          </p:cNvPr>
+          <p:cNvSpPr/>
+          <p:nvPr/>
+        </p:nvSpPr>
+        <p:spPr>
+          <a:xfrm>
+            <a:off x="4380992" y="2530722"/>
+            <a:ext cx="1266352" cy="136899"/>
           </a:xfrm>
           <a:prstGeom prst="rect">
             <a:avLst/>
@@ -3793,7 +3576,7 @@
                 <a:ea typeface="Arial" pitchFamily="34" charset="-122"/>
                 <a:cs typeface="Arial" pitchFamily="34" charset="-120"/>
               </a:rPr>
-              <a:t>Harmonised analysis grid</a:t>
+              <a:t>Sampling units</a:t>
             </a:r>
             <a:endParaRPr lang="en-US" sz="1200" dirty="0"/>
           </a:p>
@@ -3801,20 +3584,20 @@
       </p:sp>
       <p:sp>
         <p:nvSpPr>
-          <p:cNvPr id="54" name="Text 52">
-            <a:extLst>
-              <a:ext uri="{FF2B5EF4-FFF2-40B4-BE49-F238E27FC236}">
-                <a16:creationId xmlns:a16="http://schemas.microsoft.com/office/drawing/2014/main" id="{514C462E-3968-62E9-FA4B-4277777731CD}"/>
-              </a:ext>
-            </a:extLst>
-          </p:cNvPr>
-          <p:cNvSpPr/>
-          <p:nvPr/>
-        </p:nvSpPr>
-        <p:spPr>
-          <a:xfrm>
-            <a:off x="1901952" y="2774708"/>
-            <a:ext cx="1828800" cy="246888"/>
+          <p:cNvPr id="57" name="Text 55">
+            <a:extLst>
+              <a:ext uri="{FF2B5EF4-FFF2-40B4-BE49-F238E27FC236}">
+                <a16:creationId xmlns:a16="http://schemas.microsoft.com/office/drawing/2014/main" id="{A00A9F71-D4AF-B9A6-4490-71465C4CBC2A}"/>
+              </a:ext>
+            </a:extLst>
+          </p:cNvPr>
+          <p:cNvSpPr/>
+          <p:nvPr/>
+        </p:nvSpPr>
+        <p:spPr>
+          <a:xfrm>
+            <a:off x="4145534" y="2764644"/>
+            <a:ext cx="1920240" cy="283464"/>
           </a:xfrm>
           <a:prstGeom prst="rect">
             <a:avLst/>
@@ -3824,7 +3607,7 @@
         </p:spPr>
         <p:txBody>
           <a:bodyPr wrap="square" lIns="0" tIns="0" rIns="0" bIns="0" rtlCol="0" anchor="ctr">
-            <a:normAutofit/>
+            <a:noAutofit/>
           </a:bodyPr>
           <a:lstStyle/>
           <a:p>
@@ -3840,32 +3623,187 @@
                 <a:ea typeface="Arial" pitchFamily="34" charset="-122"/>
                 <a:cs typeface="Arial" pitchFamily="34" charset="-120"/>
               </a:rPr>
-              <a:t>0.25° · annual · 1982-2021</a:t>
+              <a:t>IPCC AR6 region × biome</a:t>
             </a:r>
             <a:endParaRPr lang="en-US" sz="1000" dirty="0"/>
           </a:p>
         </p:txBody>
       </p:sp>
-      <p:sp>
-        <p:nvSpPr>
-          <p:cNvPr id="55" name="Shape 53">
-            <a:extLst>
-              <a:ext uri="{FF2B5EF4-FFF2-40B4-BE49-F238E27FC236}">
-                <a16:creationId xmlns:a16="http://schemas.microsoft.com/office/drawing/2014/main" id="{6E843CC2-1F2F-C3E0-D455-965A695B59AD}"/>
-              </a:ext>
-            </a:extLst>
-          </p:cNvPr>
-          <p:cNvSpPr/>
-          <p:nvPr/>
-        </p:nvSpPr>
-        <p:spPr>
-          <a:xfrm>
-            <a:off x="3895344" y="2497226"/>
+      <p:grpSp>
+        <p:nvGrpSpPr>
+          <p:cNvPr id="49" name="Group 48">
+            <a:extLst>
+              <a:ext uri="{FF2B5EF4-FFF2-40B4-BE49-F238E27FC236}">
+                <a16:creationId xmlns:a16="http://schemas.microsoft.com/office/drawing/2014/main" id="{A5B56611-BF48-0EF1-79DB-B0ADBF59D012}"/>
+              </a:ext>
+            </a:extLst>
+          </p:cNvPr>
+          <p:cNvGrpSpPr/>
+          <p:nvPr/>
+        </p:nvGrpSpPr>
+        <p:grpSpPr>
+          <a:xfrm>
+            <a:off x="1728216" y="3726954"/>
+            <a:ext cx="4187952" cy="502920"/>
+            <a:chOff x="1719072" y="3859682"/>
+            <a:chExt cx="4187952" cy="502920"/>
+          </a:xfrm>
+        </p:grpSpPr>
+        <p:sp>
+          <p:nvSpPr>
+            <p:cNvPr id="63" name="Shape 61">
+              <a:extLst>
+                <a:ext uri="{FF2B5EF4-FFF2-40B4-BE49-F238E27FC236}">
+                  <a16:creationId xmlns:a16="http://schemas.microsoft.com/office/drawing/2014/main" id="{7E46545D-7FE4-5BD5-6B46-202F9EFAAFE7}"/>
+                </a:ext>
+              </a:extLst>
+            </p:cNvPr>
+            <p:cNvSpPr/>
+            <p:nvPr/>
+          </p:nvSpPr>
+          <p:spPr>
+            <a:xfrm>
+              <a:off x="1719072" y="3859682"/>
+              <a:ext cx="4187952" cy="502920"/>
+            </a:xfrm>
+            <a:prstGeom prst="roundRect">
+              <a:avLst>
+                <a:gd name="adj" fmla="val 14545"/>
+              </a:avLst>
+            </a:prstGeom>
+            <a:solidFill>
+              <a:srgbClr val="FFFFFF"/>
+            </a:solidFill>
+            <a:ln w="13335">
+              <a:solidFill>
+                <a:srgbClr val="3275A5"/>
+              </a:solidFill>
+              <a:prstDash val="solid"/>
+            </a:ln>
+          </p:spPr>
+          <p:txBody>
+            <a:bodyPr/>
+            <a:lstStyle/>
+            <a:p>
+              <a:endParaRPr lang="en-US"/>
+            </a:p>
+          </p:txBody>
+        </p:sp>
+        <p:sp>
+          <p:nvSpPr>
+            <p:cNvPr id="64" name="Text 62">
+              <a:extLst>
+                <a:ext uri="{FF2B5EF4-FFF2-40B4-BE49-F238E27FC236}">
+                  <a16:creationId xmlns:a16="http://schemas.microsoft.com/office/drawing/2014/main" id="{0238A162-912A-4C6F-DB2C-8AB6B2BDCB44}"/>
+                </a:ext>
+              </a:extLst>
+            </p:cNvPr>
+            <p:cNvSpPr/>
+            <p:nvPr/>
+          </p:nvSpPr>
+          <p:spPr>
+            <a:xfrm>
+              <a:off x="1816795" y="3875083"/>
+              <a:ext cx="4005072" cy="164592"/>
+            </a:xfrm>
+            <a:prstGeom prst="rect">
+              <a:avLst/>
+            </a:prstGeom>
+            <a:noFill/>
+            <a:ln/>
+          </p:spPr>
+          <p:txBody>
+            <a:bodyPr wrap="square" lIns="0" tIns="0" rIns="0" bIns="0" rtlCol="0" anchor="ctr">
+              <a:noAutofit/>
+            </a:bodyPr>
+            <a:lstStyle/>
+            <a:p>
+              <a:pPr marL="0" indent="0" algn="ctr">
+                <a:buNone/>
+              </a:pPr>
+              <a:r>
+                <a:rPr lang="en-US" sz="1200" b="1" dirty="0">
+                  <a:solidFill>
+                    <a:srgbClr val="3275A5"/>
+                  </a:solidFill>
+                  <a:latin typeface="Arial" pitchFamily="34" charset="0"/>
+                  <a:ea typeface="Arial" pitchFamily="34" charset="-122"/>
+                  <a:cs typeface="Arial" pitchFamily="34" charset="-120"/>
+                </a:rPr>
+                <a:t>Leave-one-out ensemble agreement</a:t>
+              </a:r>
+              <a:endParaRPr lang="en-US" sz="1200" dirty="0"/>
+            </a:p>
+          </p:txBody>
+        </p:sp>
+        <p:sp>
+          <p:nvSpPr>
+            <p:cNvPr id="65" name="Text 63">
+              <a:extLst>
+                <a:ext uri="{FF2B5EF4-FFF2-40B4-BE49-F238E27FC236}">
+                  <a16:creationId xmlns:a16="http://schemas.microsoft.com/office/drawing/2014/main" id="{10582E4C-C597-3AEE-3179-0CE0FAC4E87F}"/>
+                </a:ext>
+              </a:extLst>
+            </p:cNvPr>
+            <p:cNvSpPr/>
+            <p:nvPr/>
+          </p:nvSpPr>
+          <p:spPr>
+            <a:xfrm>
+              <a:off x="1810512" y="4143103"/>
+              <a:ext cx="4005072" cy="164592"/>
+            </a:xfrm>
+            <a:prstGeom prst="rect">
+              <a:avLst/>
+            </a:prstGeom>
+            <a:noFill/>
+            <a:ln/>
+          </p:spPr>
+          <p:txBody>
+            <a:bodyPr wrap="square" lIns="0" tIns="0" rIns="0" bIns="0" rtlCol="0" anchor="ctr">
+              <a:normAutofit/>
+            </a:bodyPr>
+            <a:lstStyle/>
+            <a:p>
+              <a:pPr marL="0" indent="0" algn="ctr">
+                <a:buNone/>
+              </a:pPr>
+              <a:r>
+                <a:rPr lang="en-US" sz="1000" dirty="0">
+                  <a:solidFill>
+                    <a:srgbClr val="25322D"/>
+                  </a:solidFill>
+                  <a:latin typeface="Arial" pitchFamily="34" charset="0"/>
+                  <a:ea typeface="Arial" pitchFamily="34" charset="-122"/>
+                  <a:cs typeface="Arial" pitchFamily="34" charset="-120"/>
+                </a:rPr>
+                <a:t>climatology - variability - trend - sign/significance</a:t>
+              </a:r>
+              <a:endParaRPr lang="en-US" sz="1000" dirty="0"/>
+            </a:p>
+          </p:txBody>
+        </p:sp>
+      </p:grpSp>
+      <p:sp>
+        <p:nvSpPr>
+          <p:cNvPr id="66" name="Shape 64">
+            <a:extLst>
+              <a:ext uri="{FF2B5EF4-FFF2-40B4-BE49-F238E27FC236}">
+                <a16:creationId xmlns:a16="http://schemas.microsoft.com/office/drawing/2014/main" id="{A7E11896-28BF-FA01-C1A5-1AFFEC73BF40}"/>
+              </a:ext>
+            </a:extLst>
+          </p:cNvPr>
+          <p:cNvSpPr/>
+          <p:nvPr/>
+        </p:nvSpPr>
+        <p:spPr>
+          <a:xfrm>
+            <a:off x="1691132" y="4338286"/>
             <a:ext cx="2103120" cy="722376"/>
           </a:xfrm>
           <a:prstGeom prst="roundRect">
             <a:avLst>
-              <a:gd name="adj" fmla="val 11429"/>
+              <a:gd name="adj" fmla="val 13793"/>
             </a:avLst>
           </a:prstGeom>
           <a:solidFill>
@@ -3888,455 +3826,6 @@
       </p:sp>
       <p:sp>
         <p:nvSpPr>
-          <p:cNvPr id="56" name="Text 54">
-            <a:extLst>
-              <a:ext uri="{FF2B5EF4-FFF2-40B4-BE49-F238E27FC236}">
-                <a16:creationId xmlns:a16="http://schemas.microsoft.com/office/drawing/2014/main" id="{443DE53F-6FF8-07AA-C26F-415FA20B11E9}"/>
-              </a:ext>
-            </a:extLst>
-          </p:cNvPr>
-          <p:cNvSpPr/>
-          <p:nvPr/>
-        </p:nvSpPr>
-        <p:spPr>
-          <a:xfrm>
-            <a:off x="3986783" y="2511747"/>
-            <a:ext cx="2130552" cy="164592"/>
-          </a:xfrm>
-          <a:prstGeom prst="rect">
-            <a:avLst/>
-          </a:prstGeom>
-          <a:noFill/>
-          <a:ln/>
-        </p:spPr>
-        <p:txBody>
-          <a:bodyPr wrap="square" lIns="0" tIns="0" rIns="0" bIns="0" rtlCol="0" anchor="ctr">
-            <a:noAutofit/>
-          </a:bodyPr>
-          <a:lstStyle/>
-          <a:p>
-            <a:pPr marL="0" indent="0">
-              <a:buNone/>
-            </a:pPr>
-            <a:r>
-              <a:rPr lang="en-US" sz="1200" b="1" dirty="0">
-                <a:solidFill>
-                  <a:srgbClr val="3275A5"/>
-                </a:solidFill>
-                <a:latin typeface="Arial" pitchFamily="34" charset="0"/>
-                <a:ea typeface="Arial" pitchFamily="34" charset="-122"/>
-                <a:cs typeface="Arial" pitchFamily="34" charset="-120"/>
-              </a:rPr>
-              <a:t>Sampling units and masks</a:t>
-            </a:r>
-            <a:endParaRPr lang="en-US" sz="1200" dirty="0"/>
-          </a:p>
-        </p:txBody>
-      </p:sp>
-      <p:sp>
-        <p:nvSpPr>
-          <p:cNvPr id="57" name="Text 55">
-            <a:extLst>
-              <a:ext uri="{FF2B5EF4-FFF2-40B4-BE49-F238E27FC236}">
-                <a16:creationId xmlns:a16="http://schemas.microsoft.com/office/drawing/2014/main" id="{A00A9F71-D4AF-B9A6-4490-71465C4CBC2A}"/>
-              </a:ext>
-            </a:extLst>
-          </p:cNvPr>
-          <p:cNvSpPr/>
-          <p:nvPr/>
-        </p:nvSpPr>
-        <p:spPr>
-          <a:xfrm>
-            <a:off x="4145534" y="2764644"/>
-            <a:ext cx="1920240" cy="283464"/>
-          </a:xfrm>
-          <a:prstGeom prst="rect">
-            <a:avLst/>
-          </a:prstGeom>
-          <a:noFill/>
-          <a:ln/>
-        </p:spPr>
-        <p:txBody>
-          <a:bodyPr wrap="square" lIns="0" tIns="0" rIns="0" bIns="0" rtlCol="0" anchor="ctr">
-            <a:noAutofit/>
-          </a:bodyPr>
-          <a:lstStyle/>
-          <a:p>
-            <a:pPr marL="0" indent="0">
-              <a:buNone/>
-            </a:pPr>
-            <a:r>
-              <a:rPr lang="en-US" sz="1000" dirty="0">
-                <a:solidFill>
-                  <a:srgbClr val="25322D"/>
-                </a:solidFill>
-                <a:latin typeface="Arial" pitchFamily="34" charset="0"/>
-                <a:ea typeface="Arial" pitchFamily="34" charset="-122"/>
-                <a:cs typeface="Arial" pitchFamily="34" charset="-120"/>
-              </a:rPr>
-              <a:t>IPCC AR6 region x biome</a:t>
-            </a:r>
-            <a:endParaRPr lang="en-US" sz="1000" dirty="0"/>
-          </a:p>
-        </p:txBody>
-      </p:sp>
-      <p:sp>
-        <p:nvSpPr>
-          <p:cNvPr id="58" name="Shape 56">
-            <a:extLst>
-              <a:ext uri="{FF2B5EF4-FFF2-40B4-BE49-F238E27FC236}">
-                <a16:creationId xmlns:a16="http://schemas.microsoft.com/office/drawing/2014/main" id="{52D7130F-E0ED-4D17-3B8C-0A250D521DE5}"/>
-              </a:ext>
-            </a:extLst>
-          </p:cNvPr>
-          <p:cNvSpPr/>
-          <p:nvPr/>
-        </p:nvSpPr>
-        <p:spPr>
-          <a:xfrm>
-            <a:off x="6254496" y="2488039"/>
-            <a:ext cx="1170432" cy="640080"/>
-          </a:xfrm>
-          <a:prstGeom prst="roundRect">
-            <a:avLst>
-              <a:gd name="adj" fmla="val 9756"/>
-            </a:avLst>
-          </a:prstGeom>
-          <a:solidFill>
-            <a:srgbClr val="F6F6F0"/>
-          </a:solidFill>
-          <a:ln w="12700">
-            <a:solidFill>
-              <a:srgbClr val="B8B3A4"/>
-            </a:solidFill>
-            <a:prstDash val="solid"/>
-          </a:ln>
-        </p:spPr>
-        <p:txBody>
-          <a:bodyPr/>
-          <a:lstStyle/>
-          <a:p>
-            <a:endParaRPr lang="en-US" sz="2400" dirty="0"/>
-          </a:p>
-        </p:txBody>
-      </p:sp>
-      <p:sp>
-        <p:nvSpPr>
-          <p:cNvPr id="60" name="Text 58">
-            <a:extLst>
-              <a:ext uri="{FF2B5EF4-FFF2-40B4-BE49-F238E27FC236}">
-                <a16:creationId xmlns:a16="http://schemas.microsoft.com/office/drawing/2014/main" id="{FB25F7D1-57B8-99A5-404F-9F3001A8A4FE}"/>
-              </a:ext>
-            </a:extLst>
-          </p:cNvPr>
-          <p:cNvSpPr/>
-          <p:nvPr/>
-        </p:nvSpPr>
-        <p:spPr>
-          <a:xfrm>
-            <a:off x="6273546" y="2524615"/>
-            <a:ext cx="1170432" cy="164592"/>
-          </a:xfrm>
-          <a:prstGeom prst="rect">
-            <a:avLst/>
-          </a:prstGeom>
-          <a:noFill/>
-          <a:ln/>
-        </p:spPr>
-        <p:txBody>
-          <a:bodyPr wrap="square" lIns="0" tIns="0" rIns="0" bIns="0" rtlCol="0" anchor="ctr">
-            <a:noAutofit/>
-          </a:bodyPr>
-          <a:lstStyle/>
-          <a:p>
-            <a:pPr marL="0" indent="0">
-              <a:buNone/>
-            </a:pPr>
-            <a:r>
-              <a:rPr lang="en-US" sz="1050" b="1" dirty="0">
-                <a:solidFill>
-                  <a:srgbClr val="25322D"/>
-                </a:solidFill>
-                <a:latin typeface="Arial" pitchFamily="34" charset="0"/>
-                <a:ea typeface="Arial" pitchFamily="34" charset="-122"/>
-                <a:cs typeface="Arial" pitchFamily="34" charset="-120"/>
-              </a:rPr>
-              <a:t>Harmonised fields</a:t>
-            </a:r>
-            <a:endParaRPr lang="en-US" sz="1050" dirty="0"/>
-          </a:p>
-        </p:txBody>
-      </p:sp>
-      <p:sp>
-        <p:nvSpPr>
-          <p:cNvPr id="61" name="Text 59">
-            <a:extLst>
-              <a:ext uri="{FF2B5EF4-FFF2-40B4-BE49-F238E27FC236}">
-                <a16:creationId xmlns:a16="http://schemas.microsoft.com/office/drawing/2014/main" id="{7B8B5D4D-258A-ACE8-E756-455AF6FB1066}"/>
-              </a:ext>
-            </a:extLst>
-          </p:cNvPr>
-          <p:cNvSpPr/>
-          <p:nvPr/>
-        </p:nvSpPr>
-        <p:spPr>
-          <a:xfrm>
-            <a:off x="6332220" y="2798935"/>
-            <a:ext cx="1005840" cy="219456"/>
-          </a:xfrm>
-          <a:prstGeom prst="rect">
-            <a:avLst/>
-          </a:prstGeom>
-          <a:noFill/>
-          <a:ln/>
-        </p:spPr>
-        <p:txBody>
-          <a:bodyPr wrap="square" lIns="0" tIns="0" rIns="0" bIns="0" rtlCol="0" anchor="ctr">
-            <a:noAutofit/>
-          </a:bodyPr>
-          <a:lstStyle/>
-          <a:p>
-            <a:pPr marL="0" indent="0">
-              <a:buNone/>
-            </a:pPr>
-            <a:r>
-              <a:rPr lang="en-US" sz="900" dirty="0">
-                <a:solidFill>
-                  <a:srgbClr val="667269"/>
-                </a:solidFill>
-                <a:latin typeface="Arial" pitchFamily="34" charset="0"/>
-                <a:ea typeface="Arial" pitchFamily="34" charset="-122"/>
-                <a:cs typeface="Arial" pitchFamily="34" charset="-120"/>
-              </a:rPr>
-              <a:t>Annual P/E grids and class atlas</a:t>
-            </a:r>
-            <a:endParaRPr lang="en-US" sz="900" dirty="0"/>
-          </a:p>
-        </p:txBody>
-      </p:sp>
-      <p:sp>
-        <p:nvSpPr>
-          <p:cNvPr id="62" name="Text 60">
-            <a:extLst>
-              <a:ext uri="{FF2B5EF4-FFF2-40B4-BE49-F238E27FC236}">
-                <a16:creationId xmlns:a16="http://schemas.microsoft.com/office/drawing/2014/main" id="{9C8B4DE5-7E0C-7085-6B8F-B18CE0C1AE61}"/>
-              </a:ext>
-            </a:extLst>
-          </p:cNvPr>
-          <p:cNvSpPr/>
-          <p:nvPr/>
-        </p:nvSpPr>
-        <p:spPr>
-          <a:xfrm>
-            <a:off x="2794000" y="3631038"/>
-            <a:ext cx="3173984" cy="163069"/>
-          </a:xfrm>
-          <a:prstGeom prst="rect">
-            <a:avLst/>
-          </a:prstGeom>
-          <a:noFill/>
-          <a:ln/>
-        </p:spPr>
-        <p:txBody>
-          <a:bodyPr wrap="square" lIns="0" tIns="0" rIns="0" bIns="0" rtlCol="0" anchor="ctr">
-            <a:normAutofit fontScale="92500"/>
-          </a:bodyPr>
-          <a:lstStyle/>
-          <a:p>
-            <a:pPr marL="0" indent="0" algn="r">
-              <a:buNone/>
-            </a:pPr>
-            <a:r>
-              <a:rPr lang="en-US" sz="1100" b="1" dirty="0">
-                <a:solidFill>
-                  <a:srgbClr val="667269"/>
-                </a:solidFill>
-                <a:latin typeface="Arial" pitchFamily="34" charset="0"/>
-                <a:ea typeface="Arial" pitchFamily="34" charset="-122"/>
-                <a:cs typeface="Arial" pitchFamily="34" charset="-120"/>
-              </a:rPr>
-              <a:t>Validation side input: GRACE · ESA CCI · ROBIN</a:t>
-            </a:r>
-            <a:endParaRPr lang="en-US" sz="1100" dirty="0"/>
-          </a:p>
-        </p:txBody>
-      </p:sp>
-      <p:sp>
-        <p:nvSpPr>
-          <p:cNvPr id="63" name="Shape 61">
-            <a:extLst>
-              <a:ext uri="{FF2B5EF4-FFF2-40B4-BE49-F238E27FC236}">
-                <a16:creationId xmlns:a16="http://schemas.microsoft.com/office/drawing/2014/main" id="{7E46545D-7FE4-5BD5-6B46-202F9EFAAFE7}"/>
-              </a:ext>
-            </a:extLst>
-          </p:cNvPr>
-          <p:cNvSpPr/>
-          <p:nvPr/>
-        </p:nvSpPr>
-        <p:spPr>
-          <a:xfrm>
-            <a:off x="1719072" y="3859682"/>
-            <a:ext cx="4187952" cy="502920"/>
-          </a:xfrm>
-          <a:prstGeom prst="roundRect">
-            <a:avLst>
-              <a:gd name="adj" fmla="val 14545"/>
-            </a:avLst>
-          </a:prstGeom>
-          <a:solidFill>
-            <a:srgbClr val="FFFFFF"/>
-          </a:solidFill>
-          <a:ln w="13335">
-            <a:solidFill>
-              <a:srgbClr val="3275A5"/>
-            </a:solidFill>
-            <a:prstDash val="solid"/>
-          </a:ln>
-        </p:spPr>
-        <p:txBody>
-          <a:bodyPr/>
-          <a:lstStyle/>
-          <a:p>
-            <a:endParaRPr lang="en-US"/>
-          </a:p>
-        </p:txBody>
-      </p:sp>
-      <p:sp>
-        <p:nvSpPr>
-          <p:cNvPr id="64" name="Text 62">
-            <a:extLst>
-              <a:ext uri="{FF2B5EF4-FFF2-40B4-BE49-F238E27FC236}">
-                <a16:creationId xmlns:a16="http://schemas.microsoft.com/office/drawing/2014/main" id="{0238A162-912A-4C6F-DB2C-8AB6B2BDCB44}"/>
-              </a:ext>
-            </a:extLst>
-          </p:cNvPr>
-          <p:cNvSpPr/>
-          <p:nvPr/>
-        </p:nvSpPr>
-        <p:spPr>
-          <a:xfrm>
-            <a:off x="1816795" y="3875083"/>
-            <a:ext cx="4005072" cy="164592"/>
-          </a:xfrm>
-          <a:prstGeom prst="rect">
-            <a:avLst/>
-          </a:prstGeom>
-          <a:noFill/>
-          <a:ln/>
-        </p:spPr>
-        <p:txBody>
-          <a:bodyPr wrap="square" lIns="0" tIns="0" rIns="0" bIns="0" rtlCol="0" anchor="ctr">
-            <a:noAutofit/>
-          </a:bodyPr>
-          <a:lstStyle/>
-          <a:p>
-            <a:pPr marL="0" indent="0" algn="ctr">
-              <a:buNone/>
-            </a:pPr>
-            <a:r>
-              <a:rPr lang="en-US" sz="1200" b="1" dirty="0">
-                <a:solidFill>
-                  <a:srgbClr val="3275A5"/>
-                </a:solidFill>
-                <a:latin typeface="Arial" pitchFamily="34" charset="0"/>
-                <a:ea typeface="Arial" pitchFamily="34" charset="-122"/>
-                <a:cs typeface="Arial" pitchFamily="34" charset="-120"/>
-              </a:rPr>
-              <a:t>Leave-one-out reference agreement</a:t>
-            </a:r>
-            <a:endParaRPr lang="en-US" sz="1200" dirty="0"/>
-          </a:p>
-        </p:txBody>
-      </p:sp>
-      <p:sp>
-        <p:nvSpPr>
-          <p:cNvPr id="65" name="Text 63">
-            <a:extLst>
-              <a:ext uri="{FF2B5EF4-FFF2-40B4-BE49-F238E27FC236}">
-                <a16:creationId xmlns:a16="http://schemas.microsoft.com/office/drawing/2014/main" id="{10582E4C-C597-3AEE-3179-0CE0FAC4E87F}"/>
-              </a:ext>
-            </a:extLst>
-          </p:cNvPr>
-          <p:cNvSpPr/>
-          <p:nvPr/>
-        </p:nvSpPr>
-        <p:spPr>
-          <a:xfrm>
-            <a:off x="1810512" y="4143103"/>
-            <a:ext cx="4005072" cy="164592"/>
-          </a:xfrm>
-          <a:prstGeom prst="rect">
-            <a:avLst/>
-          </a:prstGeom>
-          <a:noFill/>
-          <a:ln/>
-        </p:spPr>
-        <p:txBody>
-          <a:bodyPr wrap="square" lIns="0" tIns="0" rIns="0" bIns="0" rtlCol="0" anchor="ctr">
-            <a:normAutofit/>
-          </a:bodyPr>
-          <a:lstStyle/>
-          <a:p>
-            <a:pPr marL="0" indent="0" algn="ctr">
-              <a:buNone/>
-            </a:pPr>
-            <a:r>
-              <a:rPr lang="en-US" sz="1000" dirty="0">
-                <a:solidFill>
-                  <a:srgbClr val="25322D"/>
-                </a:solidFill>
-                <a:latin typeface="Arial" pitchFamily="34" charset="0"/>
-                <a:ea typeface="Arial" pitchFamily="34" charset="-122"/>
-                <a:cs typeface="Arial" pitchFamily="34" charset="-120"/>
-              </a:rPr>
-              <a:t>climatology · variability · trend · sign/significance</a:t>
-            </a:r>
-            <a:endParaRPr lang="en-US" sz="1000" dirty="0"/>
-          </a:p>
-        </p:txBody>
-      </p:sp>
-      <p:sp>
-        <p:nvSpPr>
-          <p:cNvPr id="66" name="Shape 64">
-            <a:extLst>
-              <a:ext uri="{FF2B5EF4-FFF2-40B4-BE49-F238E27FC236}">
-                <a16:creationId xmlns:a16="http://schemas.microsoft.com/office/drawing/2014/main" id="{A7E11896-28BF-FA01-C1A5-1AFFEC73BF40}"/>
-              </a:ext>
-            </a:extLst>
-          </p:cNvPr>
-          <p:cNvSpPr/>
-          <p:nvPr/>
-        </p:nvSpPr>
-        <p:spPr>
-          <a:xfrm>
-            <a:off x="1719072" y="4461357"/>
-            <a:ext cx="2103120" cy="722376"/>
-          </a:xfrm>
-          <a:prstGeom prst="roundRect">
-            <a:avLst>
-              <a:gd name="adj" fmla="val 13793"/>
-            </a:avLst>
-          </a:prstGeom>
-          <a:solidFill>
-            <a:srgbClr val="FFFFFF"/>
-          </a:solidFill>
-          <a:ln w="13335">
-            <a:solidFill>
-              <a:srgbClr val="3275A5"/>
-            </a:solidFill>
-            <a:prstDash val="solid"/>
-          </a:ln>
-        </p:spPr>
-        <p:txBody>
-          <a:bodyPr/>
-          <a:lstStyle/>
-          <a:p>
-            <a:endParaRPr lang="en-US"/>
-          </a:p>
-        </p:txBody>
-      </p:sp>
-      <p:sp>
-        <p:nvSpPr>
           <p:cNvPr id="67" name="Text 65">
             <a:extLst>
               <a:ext uri="{FF2B5EF4-FFF2-40B4-BE49-F238E27FC236}">
@@ -4349,7 +3838,7 @@
         </p:nvSpPr>
         <p:spPr>
           <a:xfrm>
-            <a:off x="1747011" y="4478589"/>
+            <a:off x="1719071" y="4355518"/>
             <a:ext cx="2239772" cy="153924"/>
           </a:xfrm>
           <a:prstGeom prst="rect">
@@ -4396,7 +3885,7 @@
         </p:nvSpPr>
         <p:spPr>
           <a:xfrm>
-            <a:off x="1816608" y="4805966"/>
+            <a:off x="1788668" y="4682895"/>
             <a:ext cx="1816608" cy="210312"/>
           </a:xfrm>
           <a:prstGeom prst="rect">
@@ -4423,7 +3912,7 @@
                 <a:ea typeface="Arial" pitchFamily="34" charset="-122"/>
                 <a:cs typeface="Arial" pitchFamily="34" charset="-120"/>
               </a:rPr>
-              <a:t>P/E aridity consistency</a:t>
+              <a:t>P/E &gt; 0.9</a:t>
             </a:r>
             <a:endParaRPr lang="en-US" sz="1000" dirty="0"/>
           </a:p>
@@ -4460,7 +3949,7 @@
         </p:nvSpPr>
         <p:spPr>
           <a:xfrm>
-            <a:off x="3895344" y="4461357"/>
+            <a:off x="3867404" y="4338286"/>
             <a:ext cx="2103120" cy="722376"/>
           </a:xfrm>
           <a:prstGeom prst="roundRect">
@@ -4500,7 +3989,7 @@
         </p:nvSpPr>
         <p:spPr>
           <a:xfrm>
-            <a:off x="3986783" y="4484863"/>
+            <a:off x="3958843" y="4361792"/>
             <a:ext cx="1920240" cy="164592"/>
           </a:xfrm>
           <a:prstGeom prst="rect">
@@ -4527,7 +4016,7 @@
                 <a:ea typeface="Arial" pitchFamily="34" charset="-122"/>
                 <a:cs typeface="Arial" pitchFamily="34" charset="-120"/>
               </a:rPr>
-              <a:t>Quality gate</a:t>
+              <a:t>Plausibility check</a:t>
             </a:r>
             <a:endParaRPr lang="en-US" sz="1200" dirty="0"/>
           </a:p>
@@ -4547,7 +4036,7 @@
         </p:nvSpPr>
         <p:spPr>
           <a:xfrm>
-            <a:off x="3986784" y="4797463"/>
+            <a:off x="3958844" y="4674392"/>
             <a:ext cx="1920240" cy="210312"/>
           </a:xfrm>
           <a:prstGeom prst="rect">
@@ -4562,9 +4051,7 @@
           </a:bodyPr>
           <a:lstStyle/>
           <a:p>
-            <a:pPr marL="0" indent="0" algn="ctr">
-              <a:buNone/>
-            </a:pPr>
+            <a:pPr algn="ctr"/>
             <a:r>
               <a:rPr lang="en-US" sz="1000" dirty="0">
                 <a:solidFill>
@@ -4574,161 +4061,10 @@
                 <a:ea typeface="Arial" pitchFamily="34" charset="-122"/>
                 <a:cs typeface="Arial" pitchFamily="34" charset="-120"/>
               </a:rPr>
-              <a:t>aridity pass + n_below_pet &gt; 6</a:t>
+              <a:t>P/E &gt; 0.9 &amp; AET &lt; PET for at least half PET combinations</a:t>
             </a:r>
             <a:endParaRPr lang="en-US" sz="1000" dirty="0"/>
           </a:p>
-          <a:p>
-            <a:pPr marL="0" indent="0" algn="ctr">
-              <a:buNone/>
-            </a:pPr>
-            <a:r>
-              <a:rPr lang="en-US" sz="1000" dirty="0">
-                <a:solidFill>
-                  <a:srgbClr val="25322D"/>
-                </a:solidFill>
-                <a:latin typeface="Arial" pitchFamily="34" charset="0"/>
-                <a:ea typeface="Arial" pitchFamily="34" charset="-122"/>
-                <a:cs typeface="Arial" pitchFamily="34" charset="-120"/>
-              </a:rPr>
-              <a:t>limitation mask</a:t>
-            </a:r>
-            <a:endParaRPr lang="en-US" sz="1000" dirty="0"/>
-          </a:p>
-        </p:txBody>
-      </p:sp>
-      <p:sp>
-        <p:nvSpPr>
-          <p:cNvPr id="72" name="Shape 70">
-            <a:extLst>
-              <a:ext uri="{FF2B5EF4-FFF2-40B4-BE49-F238E27FC236}">
-                <a16:creationId xmlns:a16="http://schemas.microsoft.com/office/drawing/2014/main" id="{A021725F-9BDE-5CFF-1631-91A12DE317F9}"/>
-              </a:ext>
-            </a:extLst>
-          </p:cNvPr>
-          <p:cNvSpPr/>
-          <p:nvPr/>
-        </p:nvSpPr>
-        <p:spPr>
-          <a:xfrm>
-            <a:off x="6254496" y="4051663"/>
-            <a:ext cx="1170432" cy="640080"/>
-          </a:xfrm>
-          <a:prstGeom prst="roundRect">
-            <a:avLst>
-              <a:gd name="adj" fmla="val 9756"/>
-            </a:avLst>
-          </a:prstGeom>
-          <a:solidFill>
-            <a:srgbClr val="F6F6F0"/>
-          </a:solidFill>
-          <a:ln w="12700">
-            <a:solidFill>
-              <a:srgbClr val="B8B3A4"/>
-            </a:solidFill>
-            <a:prstDash val="solid"/>
-          </a:ln>
-        </p:spPr>
-        <p:txBody>
-          <a:bodyPr/>
-          <a:lstStyle/>
-          <a:p>
-            <a:endParaRPr lang="en-US" sz="2400"/>
-          </a:p>
-        </p:txBody>
-      </p:sp>
-      <p:sp>
-        <p:nvSpPr>
-          <p:cNvPr id="74" name="Text 72">
-            <a:extLst>
-              <a:ext uri="{FF2B5EF4-FFF2-40B4-BE49-F238E27FC236}">
-                <a16:creationId xmlns:a16="http://schemas.microsoft.com/office/drawing/2014/main" id="{ADC3E26D-F9C3-4DBC-E015-1B066A88811E}"/>
-              </a:ext>
-            </a:extLst>
-          </p:cNvPr>
-          <p:cNvSpPr/>
-          <p:nvPr/>
-        </p:nvSpPr>
-        <p:spPr>
-          <a:xfrm>
-            <a:off x="6317742" y="4091348"/>
-            <a:ext cx="1107186" cy="164592"/>
-          </a:xfrm>
-          <a:prstGeom prst="rect">
-            <a:avLst/>
-          </a:prstGeom>
-          <a:noFill/>
-          <a:ln/>
-        </p:spPr>
-        <p:txBody>
-          <a:bodyPr wrap="square" lIns="0" tIns="0" rIns="0" bIns="0" rtlCol="0" anchor="ctr">
-            <a:normAutofit/>
-          </a:bodyPr>
-          <a:lstStyle/>
-          <a:p>
-            <a:pPr marL="0" indent="0">
-              <a:buNone/>
-            </a:pPr>
-            <a:r>
-              <a:rPr lang="en-US" sz="900" b="1" dirty="0">
-                <a:solidFill>
-                  <a:srgbClr val="25322D"/>
-                </a:solidFill>
-                <a:latin typeface="Arial" pitchFamily="34" charset="0"/>
-                <a:ea typeface="Arial" pitchFamily="34" charset="-122"/>
-                <a:cs typeface="Arial" pitchFamily="34" charset="-120"/>
-              </a:rPr>
-              <a:t>Evaluation outputs</a:t>
-            </a:r>
-            <a:endParaRPr lang="en-US" sz="900" dirty="0"/>
-          </a:p>
-        </p:txBody>
-      </p:sp>
-      <p:sp>
-        <p:nvSpPr>
-          <p:cNvPr id="75" name="Text 73">
-            <a:extLst>
-              <a:ext uri="{FF2B5EF4-FFF2-40B4-BE49-F238E27FC236}">
-                <a16:creationId xmlns:a16="http://schemas.microsoft.com/office/drawing/2014/main" id="{174B1FC9-7B4C-868F-0DA9-FE0159221ECC}"/>
-              </a:ext>
-            </a:extLst>
-          </p:cNvPr>
-          <p:cNvSpPr/>
-          <p:nvPr/>
-        </p:nvSpPr>
-        <p:spPr>
-          <a:xfrm>
-            <a:off x="6311900" y="4344271"/>
-            <a:ext cx="1005840" cy="219456"/>
-          </a:xfrm>
-          <a:prstGeom prst="rect">
-            <a:avLst/>
-          </a:prstGeom>
-          <a:noFill/>
-          <a:ln/>
-        </p:spPr>
-        <p:txBody>
-          <a:bodyPr wrap="square" lIns="0" tIns="0" rIns="0" bIns="0" rtlCol="0" anchor="ctr">
-            <a:noAutofit/>
-          </a:bodyPr>
-          <a:lstStyle/>
-          <a:p>
-            <a:pPr marL="0" indent="0">
-              <a:buNone/>
-            </a:pPr>
-            <a:r>
-              <a:rPr lang="en-US" sz="900" dirty="0">
-                <a:solidFill>
-                  <a:srgbClr val="667269"/>
-                </a:solidFill>
-                <a:latin typeface="Arial" pitchFamily="34" charset="0"/>
-                <a:ea typeface="Arial" pitchFamily="34" charset="-122"/>
-                <a:cs typeface="Arial" pitchFamily="34" charset="-120"/>
-              </a:rPr>
-              <a:t>Scores, ranks, and gate masks</a:t>
-            </a:r>
-            <a:endParaRPr lang="en-US" sz="900" dirty="0"/>
-          </a:p>
         </p:txBody>
       </p:sp>
       <p:sp>
@@ -4745,7 +4081,7 @@
         </p:nvSpPr>
         <p:spPr>
           <a:xfrm>
-            <a:off x="1759324" y="5436979"/>
+            <a:off x="1745570" y="5485266"/>
             <a:ext cx="4187952" cy="201168"/>
           </a:xfrm>
           <a:prstGeom prst="rect">
@@ -4760,9 +4096,7 @@
           </a:bodyPr>
           <a:lstStyle/>
           <a:p>
-            <a:pPr marL="0" indent="0" algn="ctr">
-              <a:buNone/>
-            </a:pPr>
+            <a:pPr algn="ctr"/>
             <a:r>
               <a:rPr lang="en-US" sz="1200" b="1" dirty="0">
                 <a:solidFill>
@@ -4772,7 +4106,28 @@
                 <a:ea typeface="Arial" pitchFamily="34" charset="-122"/>
                 <a:cs typeface="Arial" pitchFamily="34" charset="-120"/>
               </a:rPr>
-              <a:t>Grid-cell performance → region x biome selection probabilities</a:t>
+              <a:t>Grid-cell performance → region </a:t>
+            </a:r>
+            <a:r>
+              <a:rPr lang="en-US" sz="1200" b="1" dirty="0">
+                <a:solidFill>
+                  <a:srgbClr val="3275A5"/>
+                </a:solidFill>
+                <a:latin typeface="Arial" pitchFamily="34" charset="0"/>
+                <a:cs typeface="Arial" pitchFamily="34" charset="-120"/>
+              </a:rPr>
+              <a:t>× </a:t>
+            </a:r>
+            <a:r>
+              <a:rPr lang="en-US" sz="1200" b="1" dirty="0">
+                <a:solidFill>
+                  <a:srgbClr val="3275A5"/>
+                </a:solidFill>
+                <a:latin typeface="Arial" pitchFamily="34" charset="0"/>
+                <a:ea typeface="Arial" pitchFamily="34" charset="-122"/>
+                <a:cs typeface="Arial" pitchFamily="34" charset="-120"/>
+              </a:rPr>
+              <a:t>biome selection probabilities</a:t>
             </a:r>
             <a:endParaRPr lang="en-US" sz="1200" dirty="0"/>
           </a:p>
@@ -4926,7 +4281,7 @@
         </p:nvSpPr>
         <p:spPr>
           <a:xfrm>
-            <a:off x="3895344" y="5798210"/>
+            <a:off x="3924019" y="5798210"/>
             <a:ext cx="2103120" cy="662025"/>
           </a:xfrm>
           <a:prstGeom prst="roundRect">
@@ -5117,8 +4472,8 @@
         </p:nvSpPr>
         <p:spPr>
           <a:xfrm>
-            <a:off x="2129282" y="6592734"/>
-            <a:ext cx="4005072" cy="164592"/>
+            <a:off x="3219807" y="6657787"/>
+            <a:ext cx="1259633" cy="134742"/>
           </a:xfrm>
           <a:prstGeom prst="rect">
             <a:avLst/>
@@ -5144,7 +4499,7 @@
                 <a:ea typeface="Arial" pitchFamily="34" charset="-122"/>
                 <a:cs typeface="Arial" pitchFamily="34" charset="-120"/>
               </a:rPr>
-              <a:t>Eight scenarios across two orthogonal axes</a:t>
+              <a:t>Eight scenarios</a:t>
             </a:r>
             <a:endParaRPr lang="en-US" sz="1200" dirty="0"/>
           </a:p>
@@ -5164,8 +4519,8 @@
         </p:nvSpPr>
         <p:spPr>
           <a:xfrm>
-            <a:off x="1766061" y="6922879"/>
-            <a:ext cx="4157471" cy="201168"/>
+            <a:off x="1664021" y="6872630"/>
+            <a:ext cx="4269501" cy="343815"/>
           </a:xfrm>
           <a:prstGeom prst="rect">
             <a:avLst/>
@@ -5179,9 +4534,18 @@
           </a:bodyPr>
           <a:lstStyle/>
           <a:p>
-            <a:pPr marL="0" indent="0" algn="ctr">
-              <a:buNone/>
-            </a:pPr>
+            <a:pPr algn="ctr"/>
+            <a:r>
+              <a:rPr lang="en-US" sz="1000" u="sng" dirty="0">
+                <a:solidFill>
+                  <a:srgbClr val="25322D"/>
+                </a:solidFill>
+                <a:latin typeface="Arial" pitchFamily="34" charset="0"/>
+                <a:ea typeface="Arial" pitchFamily="34" charset="-122"/>
+                <a:cs typeface="Arial" pitchFamily="34" charset="-120"/>
+              </a:rPr>
+              <a:t>Weight allocation</a:t>
+            </a:r>
             <a:r>
               <a:rPr lang="en-US" sz="1000" dirty="0">
                 <a:solidFill>
@@ -5191,14 +4555,19 @@
                 <a:ea typeface="Arial" pitchFamily="34" charset="-122"/>
                 <a:cs typeface="Arial" pitchFamily="34" charset="-120"/>
               </a:rPr>
-              <a:t>Axis 1: weighted evidence - base · climate · evaporation · precipitation</a:t>
+              <a:t>: base - climate - evap. - </a:t>
             </a:r>
-            <a:endParaRPr lang="en-US" sz="1000" dirty="0"/>
-          </a:p>
-          <a:p>
-            <a:pPr marL="0" indent="0" algn="ctr">
-              <a:buNone/>
-            </a:pPr>
+            <a:r>
+              <a:rPr lang="en-US" sz="1000" dirty="0" err="1">
+                <a:solidFill>
+                  <a:srgbClr val="25322D"/>
+                </a:solidFill>
+                <a:latin typeface="Arial" pitchFamily="34" charset="0"/>
+                <a:ea typeface="Arial" pitchFamily="34" charset="-122"/>
+                <a:cs typeface="Arial" pitchFamily="34" charset="-120"/>
+              </a:rPr>
+              <a:t>precip</a:t>
+            </a:r>
             <a:r>
               <a:rPr lang="en-US" sz="1000" dirty="0">
                 <a:solidFill>
@@ -5208,86 +4577,16 @@
                 <a:ea typeface="Arial" pitchFamily="34" charset="-122"/>
                 <a:cs typeface="Arial" pitchFamily="34" charset="-120"/>
               </a:rPr>
-              <a:t>Axis 2: probability mapping - linear · exponential · neutral · disagreement</a:t>
+              <a:t>. - weighted evidence  </a:t>
             </a:r>
             <a:endParaRPr lang="en-US" sz="1000" dirty="0"/>
           </a:p>
-        </p:txBody>
-      </p:sp>
-      <p:sp>
-        <p:nvSpPr>
-          <p:cNvPr id="86" name="Shape 84">
-            <a:extLst>
-              <a:ext uri="{FF2B5EF4-FFF2-40B4-BE49-F238E27FC236}">
-                <a16:creationId xmlns:a16="http://schemas.microsoft.com/office/drawing/2014/main" id="{2306D94D-C5F7-9D22-5565-4BD39D8840EC}"/>
-              </a:ext>
-            </a:extLst>
-          </p:cNvPr>
-          <p:cNvSpPr/>
-          <p:nvPr/>
-        </p:nvSpPr>
-        <p:spPr>
-          <a:xfrm>
-            <a:off x="6254496" y="6005431"/>
-            <a:ext cx="1170432" cy="640080"/>
-          </a:xfrm>
-          <a:prstGeom prst="roundRect">
-            <a:avLst>
-              <a:gd name="adj" fmla="val 9756"/>
-            </a:avLst>
-          </a:prstGeom>
-          <a:solidFill>
-            <a:srgbClr val="F6F6F0"/>
-          </a:solidFill>
-          <a:ln w="12700">
-            <a:solidFill>
-              <a:srgbClr val="B8B3A4"/>
-            </a:solidFill>
-            <a:prstDash val="solid"/>
-          </a:ln>
-        </p:spPr>
-        <p:txBody>
-          <a:bodyPr/>
-          <a:lstStyle/>
-          <a:p>
-            <a:endParaRPr lang="en-US" sz="2400"/>
-          </a:p>
-        </p:txBody>
-      </p:sp>
-      <p:sp>
-        <p:nvSpPr>
-          <p:cNvPr id="88" name="Text 86">
-            <a:extLst>
-              <a:ext uri="{FF2B5EF4-FFF2-40B4-BE49-F238E27FC236}">
-                <a16:creationId xmlns:a16="http://schemas.microsoft.com/office/drawing/2014/main" id="{51F6E0C4-1924-9A2F-FE96-9E6832E65C96}"/>
-              </a:ext>
-            </a:extLst>
-          </p:cNvPr>
-          <p:cNvSpPr/>
-          <p:nvPr/>
-        </p:nvSpPr>
-        <p:spPr>
-          <a:xfrm>
-            <a:off x="6311900" y="6046970"/>
-            <a:ext cx="1170432" cy="164592"/>
-          </a:xfrm>
-          <a:prstGeom prst="rect">
-            <a:avLst/>
-          </a:prstGeom>
-          <a:noFill/>
-          <a:ln/>
-        </p:spPr>
-        <p:txBody>
-          <a:bodyPr wrap="square" lIns="0" tIns="0" rIns="0" bIns="0" rtlCol="0" anchor="ctr">
-            <a:noAutofit/>
-          </a:bodyPr>
-          <a:lstStyle/>
-          <a:p>
-            <a:pPr marL="0" indent="0">
+          <a:p>
+            <a:pPr marL="0" indent="0" algn="ctr">
               <a:buNone/>
             </a:pPr>
             <a:r>
-              <a:rPr lang="en-US" sz="1050" b="1" dirty="0">
+              <a:rPr lang="en-US" sz="1000" u="sng" dirty="0">
                 <a:solidFill>
                   <a:srgbClr val="25322D"/>
                 </a:solidFill>
@@ -5295,56 +4594,20 @@
                 <a:ea typeface="Arial" pitchFamily="34" charset="-122"/>
                 <a:cs typeface="Arial" pitchFamily="34" charset="-120"/>
               </a:rPr>
-              <a:t>Scenario weights</a:t>
+              <a:t>Sampling</a:t>
             </a:r>
-            <a:endParaRPr lang="en-US" sz="1050" dirty="0"/>
-          </a:p>
-        </p:txBody>
-      </p:sp>
-      <p:sp>
-        <p:nvSpPr>
-          <p:cNvPr id="89" name="Text 87">
-            <a:extLst>
-              <a:ext uri="{FF2B5EF4-FFF2-40B4-BE49-F238E27FC236}">
-                <a16:creationId xmlns:a16="http://schemas.microsoft.com/office/drawing/2014/main" id="{82456401-099F-0D1A-5C88-193196913FBF}"/>
-              </a:ext>
-            </a:extLst>
-          </p:cNvPr>
-          <p:cNvSpPr/>
-          <p:nvPr/>
-        </p:nvSpPr>
-        <p:spPr>
-          <a:xfrm>
-            <a:off x="6311900" y="6252362"/>
-            <a:ext cx="1181862" cy="219456"/>
-          </a:xfrm>
-          <a:prstGeom prst="rect">
-            <a:avLst/>
-          </a:prstGeom>
-          <a:noFill/>
-          <a:ln/>
-        </p:spPr>
-        <p:txBody>
-          <a:bodyPr wrap="square" lIns="0" tIns="0" rIns="0" bIns="0" rtlCol="0" anchor="ctr">
-            <a:noAutofit/>
-          </a:bodyPr>
-          <a:lstStyle/>
-          <a:p>
-            <a:pPr marL="0" indent="0">
-              <a:buNone/>
-            </a:pPr>
             <a:r>
-              <a:rPr lang="en-US" sz="900" dirty="0">
+              <a:rPr lang="en-US" sz="1000" dirty="0">
                 <a:solidFill>
-                  <a:srgbClr val="667269"/>
+                  <a:srgbClr val="25322D"/>
                 </a:solidFill>
                 <a:latin typeface="Arial" pitchFamily="34" charset="0"/>
                 <a:ea typeface="Arial" pitchFamily="34" charset="-122"/>
                 <a:cs typeface="Arial" pitchFamily="34" charset="-120"/>
               </a:rPr>
-              <a:t>All 8 probability fields</a:t>
+              <a:t>: prob. mapping - linear - exponential - neutral - disagreement</a:t>
             </a:r>
-            <a:endParaRPr lang="en-US" sz="900" dirty="0"/>
+            <a:endParaRPr lang="en-US" sz="1000" dirty="0"/>
           </a:p>
         </p:txBody>
       </p:sp>
@@ -5362,7 +4625,7 @@
         </p:nvSpPr>
         <p:spPr>
           <a:xfrm>
-            <a:off x="1664021" y="7525821"/>
+            <a:off x="1664021" y="7583555"/>
             <a:ext cx="4187952" cy="201168"/>
           </a:xfrm>
           <a:prstGeom prst="rect">
@@ -5377,9 +4640,7 @@
           </a:bodyPr>
           <a:lstStyle/>
           <a:p>
-            <a:pPr marL="0" indent="0" algn="ctr">
-              <a:buNone/>
-            </a:pPr>
+            <a:pPr algn="ctr"/>
             <a:r>
               <a:rPr lang="en-US" sz="1100" b="1" dirty="0">
                 <a:solidFill>
@@ -5389,7 +4650,28 @@
                 <a:ea typeface="Arial" pitchFamily="34" charset="-122"/>
                 <a:cs typeface="Arial" pitchFamily="34" charset="-120"/>
               </a:rPr>
-              <a:t>Inverse-CDF sampling by region x biome</a:t>
+              <a:t>Inverse-CDF sampling by region </a:t>
+            </a:r>
+            <a:r>
+              <a:rPr lang="en-US" sz="1100" b="1" dirty="0">
+                <a:solidFill>
+                  <a:srgbClr val="3275A5"/>
+                </a:solidFill>
+                <a:latin typeface="Arial" pitchFamily="34" charset="0"/>
+                <a:cs typeface="Arial" pitchFamily="34" charset="-120"/>
+              </a:rPr>
+              <a:t>×</a:t>
+            </a:r>
+            <a:r>
+              <a:rPr lang="en-US" sz="1100" b="1" dirty="0">
+                <a:solidFill>
+                  <a:srgbClr val="3275A5"/>
+                </a:solidFill>
+                <a:latin typeface="Arial" pitchFamily="34" charset="0"/>
+                <a:ea typeface="Arial" pitchFamily="34" charset="-122"/>
+                <a:cs typeface="Arial" pitchFamily="34" charset="-120"/>
+              </a:rPr>
+              <a:t> biome</a:t>
             </a:r>
             <a:endParaRPr lang="en-US" sz="1100" dirty="0"/>
           </a:p>
@@ -5409,7 +4691,7 @@
         </p:nvSpPr>
         <p:spPr>
           <a:xfrm>
-            <a:off x="1719072" y="7883042"/>
+            <a:off x="1746317" y="7864710"/>
             <a:ext cx="2011680" cy="429768"/>
           </a:xfrm>
           <a:prstGeom prst="roundRect">
@@ -5523,7 +4805,7 @@
                 <a:ea typeface="Arial" pitchFamily="34" charset="-122"/>
                 <a:cs typeface="Arial" pitchFamily="34" charset="-120"/>
               </a:rPr>
-              <a:t>500 members, base scenario</a:t>
+              <a:t>500 members (base scenario)</a:t>
             </a:r>
             <a:endParaRPr lang="en-US" sz="1000" dirty="0"/>
           </a:p>
@@ -5663,156 +4945,177 @@
           </a:p>
         </p:txBody>
       </p:sp>
-      <p:sp>
-        <p:nvSpPr>
-          <p:cNvPr id="98" name="Shape 96">
-            <a:extLst>
-              <a:ext uri="{FF2B5EF4-FFF2-40B4-BE49-F238E27FC236}">
-                <a16:creationId xmlns:a16="http://schemas.microsoft.com/office/drawing/2014/main" id="{9FE0FD38-FF0D-A084-822A-6E53B71BC171}"/>
-              </a:ext>
-            </a:extLst>
-          </p:cNvPr>
-          <p:cNvSpPr/>
-          <p:nvPr/>
-        </p:nvSpPr>
-        <p:spPr>
-          <a:xfrm>
-            <a:off x="6254496" y="7805783"/>
-            <a:ext cx="1170432" cy="640080"/>
-          </a:xfrm>
-          <a:prstGeom prst="roundRect">
-            <a:avLst>
-              <a:gd name="adj" fmla="val 9756"/>
-            </a:avLst>
-          </a:prstGeom>
-          <a:solidFill>
-            <a:srgbClr val="F6F6F0"/>
-          </a:solidFill>
-          <a:ln w="12700">
+      <p:grpSp>
+        <p:nvGrpSpPr>
+          <p:cNvPr id="59" name="Group 58">
+            <a:extLst>
+              <a:ext uri="{FF2B5EF4-FFF2-40B4-BE49-F238E27FC236}">
+                <a16:creationId xmlns:a16="http://schemas.microsoft.com/office/drawing/2014/main" id="{95472960-BEE8-ACD1-BB13-6DEF44CDC2AF}"/>
+              </a:ext>
+            </a:extLst>
+          </p:cNvPr>
+          <p:cNvGrpSpPr/>
+          <p:nvPr/>
+        </p:nvGrpSpPr>
+        <p:grpSpPr>
+          <a:xfrm>
+            <a:off x="1577773" y="9105181"/>
+            <a:ext cx="2180224" cy="859536"/>
+            <a:chOff x="1577773" y="9217152"/>
+            <a:chExt cx="2180224" cy="859536"/>
+          </a:xfrm>
+        </p:grpSpPr>
+        <p:sp>
+          <p:nvSpPr>
+            <p:cNvPr id="102" name="Shape 100">
+              <a:extLst>
+                <a:ext uri="{FF2B5EF4-FFF2-40B4-BE49-F238E27FC236}">
+                  <a16:creationId xmlns:a16="http://schemas.microsoft.com/office/drawing/2014/main" id="{AC1E719C-B7FB-C1BA-146E-900085ACA228}"/>
+                </a:ext>
+              </a:extLst>
+            </p:cNvPr>
+            <p:cNvSpPr/>
+            <p:nvPr/>
+          </p:nvSpPr>
+          <p:spPr>
+            <a:xfrm>
+              <a:off x="1719072" y="9217152"/>
+              <a:ext cx="2011680" cy="859536"/>
+            </a:xfrm>
+            <a:prstGeom prst="roundRect">
+              <a:avLst>
+                <a:gd name="adj" fmla="val 11765"/>
+              </a:avLst>
+            </a:prstGeom>
             <a:solidFill>
-              <a:srgbClr val="B8B3A4"/>
+              <a:srgbClr val="FFFFFF"/>
             </a:solidFill>
-            <a:prstDash val="solid"/>
-          </a:ln>
-        </p:spPr>
-        <p:txBody>
-          <a:bodyPr/>
-          <a:lstStyle/>
-          <a:p>
-            <a:endParaRPr lang="en-US" sz="2400"/>
-          </a:p>
-        </p:txBody>
-      </p:sp>
-      <p:sp>
-        <p:nvSpPr>
-          <p:cNvPr id="100" name="Text 98">
-            <a:extLst>
-              <a:ext uri="{FF2B5EF4-FFF2-40B4-BE49-F238E27FC236}">
-                <a16:creationId xmlns:a16="http://schemas.microsoft.com/office/drawing/2014/main" id="{C4F5966B-5BFB-A1DB-E8C2-14485DE7EB40}"/>
-              </a:ext>
-            </a:extLst>
-          </p:cNvPr>
-          <p:cNvSpPr/>
-          <p:nvPr/>
-        </p:nvSpPr>
-        <p:spPr>
-          <a:xfrm>
-            <a:off x="6413246" y="7851503"/>
-            <a:ext cx="1005840" cy="164592"/>
-          </a:xfrm>
-          <a:prstGeom prst="rect">
-            <a:avLst/>
-          </a:prstGeom>
-          <a:noFill/>
-          <a:ln/>
-        </p:spPr>
-        <p:txBody>
-          <a:bodyPr wrap="square" lIns="0" tIns="0" rIns="0" bIns="0" rtlCol="0" anchor="ctr">
-            <a:normAutofit/>
-          </a:bodyPr>
-          <a:lstStyle/>
-          <a:p>
-            <a:pPr marL="0" indent="0">
-              <a:buNone/>
-            </a:pPr>
-            <a:r>
-              <a:rPr lang="en-US" sz="1050" b="1" dirty="0">
-                <a:solidFill>
-                  <a:srgbClr val="25322D"/>
-                </a:solidFill>
-                <a:latin typeface="Arial" pitchFamily="34" charset="0"/>
-                <a:ea typeface="Arial" pitchFamily="34" charset="-122"/>
-                <a:cs typeface="Arial" pitchFamily="34" charset="-120"/>
-              </a:rPr>
-              <a:t>MC records</a:t>
-            </a:r>
-            <a:endParaRPr lang="en-US" sz="1050" dirty="0"/>
-          </a:p>
-        </p:txBody>
-      </p:sp>
-      <p:sp>
-        <p:nvSpPr>
-          <p:cNvPr id="101" name="Text 99">
-            <a:extLst>
-              <a:ext uri="{FF2B5EF4-FFF2-40B4-BE49-F238E27FC236}">
-                <a16:creationId xmlns:a16="http://schemas.microsoft.com/office/drawing/2014/main" id="{2FA9AEED-27A0-2B0F-35D0-DEA18DBC22E5}"/>
-              </a:ext>
-            </a:extLst>
-          </p:cNvPr>
-          <p:cNvSpPr/>
-          <p:nvPr/>
-        </p:nvSpPr>
-        <p:spPr>
-          <a:xfrm>
-            <a:off x="6267704" y="8070959"/>
-            <a:ext cx="1145540" cy="219456"/>
-          </a:xfrm>
-          <a:prstGeom prst="rect">
-            <a:avLst/>
-          </a:prstGeom>
-          <a:noFill/>
-          <a:ln/>
-        </p:spPr>
-        <p:txBody>
-          <a:bodyPr wrap="square" lIns="0" tIns="0" rIns="0" bIns="0" rtlCol="0" anchor="ctr">
-            <a:noAutofit/>
-          </a:bodyPr>
-          <a:lstStyle/>
-          <a:p>
-            <a:pPr marL="0" indent="0">
-              <a:buNone/>
-            </a:pPr>
-            <a:r>
-              <a:rPr lang="en-US" sz="900" dirty="0">
-                <a:solidFill>
-                  <a:srgbClr val="667269"/>
-                </a:solidFill>
-                <a:latin typeface="Arial" pitchFamily="34" charset="0"/>
-                <a:ea typeface="Arial" pitchFamily="34" charset="-122"/>
-                <a:cs typeface="Arial" pitchFamily="34" charset="-120"/>
-              </a:rPr>
-              <a:t>Selections and annual ensembles</a:t>
-            </a:r>
-            <a:endParaRPr lang="en-US" sz="900" dirty="0"/>
-          </a:p>
-        </p:txBody>
-      </p:sp>
-      <p:sp>
-        <p:nvSpPr>
-          <p:cNvPr id="102" name="Shape 100">
-            <a:extLst>
-              <a:ext uri="{FF2B5EF4-FFF2-40B4-BE49-F238E27FC236}">
-                <a16:creationId xmlns:a16="http://schemas.microsoft.com/office/drawing/2014/main" id="{AC1E719C-B7FB-C1BA-146E-900085ACA228}"/>
-              </a:ext>
-            </a:extLst>
-          </p:cNvPr>
-          <p:cNvSpPr/>
-          <p:nvPr/>
-        </p:nvSpPr>
-        <p:spPr>
-          <a:xfrm>
-            <a:off x="1719072" y="9217152"/>
-            <a:ext cx="2011680" cy="859536"/>
+            <a:ln w="13335">
+              <a:solidFill>
+                <a:srgbClr val="3275A5"/>
+              </a:solidFill>
+              <a:prstDash val="solid"/>
+            </a:ln>
+          </p:spPr>
+          <p:txBody>
+            <a:bodyPr/>
+            <a:lstStyle/>
+            <a:p>
+              <a:endParaRPr lang="en-US" dirty="0"/>
+            </a:p>
+          </p:txBody>
+        </p:sp>
+        <p:sp>
+          <p:nvSpPr>
+            <p:cNvPr id="103" name="Text 101">
+              <a:extLst>
+                <a:ext uri="{FF2B5EF4-FFF2-40B4-BE49-F238E27FC236}">
+                  <a16:creationId xmlns:a16="http://schemas.microsoft.com/office/drawing/2014/main" id="{9EF43DF7-5C53-4A9B-7863-196172355C6A}"/>
+                </a:ext>
+              </a:extLst>
+            </p:cNvPr>
+            <p:cNvSpPr/>
+            <p:nvPr/>
+          </p:nvSpPr>
+          <p:spPr>
+            <a:xfrm>
+              <a:off x="1810512" y="9308193"/>
+              <a:ext cx="1567688" cy="234442"/>
+            </a:xfrm>
+            <a:prstGeom prst="rect">
+              <a:avLst/>
+            </a:prstGeom>
+            <a:noFill/>
+            <a:ln/>
+          </p:spPr>
+          <p:txBody>
+            <a:bodyPr wrap="square" lIns="0" tIns="0" rIns="0" bIns="0" rtlCol="0" anchor="ctr">
+              <a:noAutofit/>
+            </a:bodyPr>
+            <a:lstStyle/>
+            <a:p>
+              <a:pPr marL="0" indent="0" algn="ctr">
+                <a:buNone/>
+              </a:pPr>
+              <a:r>
+                <a:rPr lang="en-US" sz="1200" b="1" dirty="0">
+                  <a:solidFill>
+                    <a:srgbClr val="3275A5"/>
+                  </a:solidFill>
+                  <a:latin typeface="Arial" pitchFamily="34" charset="0"/>
+                  <a:ea typeface="Arial" pitchFamily="34" charset="-122"/>
+                  <a:cs typeface="Arial" pitchFamily="34" charset="-120"/>
+                </a:rPr>
+                <a:t>Released products</a:t>
+              </a:r>
+              <a:endParaRPr lang="en-US" sz="1200" dirty="0"/>
+            </a:p>
+          </p:txBody>
+        </p:sp>
+        <p:sp>
+          <p:nvSpPr>
+            <p:cNvPr id="104" name="Text 102">
+              <a:extLst>
+                <a:ext uri="{FF2B5EF4-FFF2-40B4-BE49-F238E27FC236}">
+                  <a16:creationId xmlns:a16="http://schemas.microsoft.com/office/drawing/2014/main" id="{4A8F015A-C4CF-66B7-7325-50D425A1A7EF}"/>
+                </a:ext>
+              </a:extLst>
+            </p:cNvPr>
+            <p:cNvSpPr/>
+            <p:nvPr/>
+          </p:nvSpPr>
+          <p:spPr>
+            <a:xfrm>
+              <a:off x="1577773" y="9644725"/>
+              <a:ext cx="2180224" cy="274320"/>
+            </a:xfrm>
+            <a:prstGeom prst="rect">
+              <a:avLst/>
+            </a:prstGeom>
+            <a:noFill/>
+            <a:ln/>
+          </p:spPr>
+          <p:txBody>
+            <a:bodyPr wrap="square" lIns="0" tIns="0" rIns="0" bIns="0" rtlCol="0" anchor="ctr">
+              <a:noAutofit/>
+            </a:bodyPr>
+            <a:lstStyle/>
+            <a:p>
+              <a:pPr marL="0" indent="0" algn="ctr">
+                <a:buNone/>
+              </a:pPr>
+              <a:r>
+                <a:rPr lang="en-US" sz="1000" dirty="0">
+                  <a:solidFill>
+                    <a:srgbClr val="25322D"/>
+                  </a:solidFill>
+                  <a:latin typeface="Arial" pitchFamily="34" charset="0"/>
+                  <a:ea typeface="Arial" pitchFamily="34" charset="-122"/>
+                  <a:cs typeface="Arial" pitchFamily="34" charset="-120"/>
+                </a:rPr>
+                <a:t>P, E, P-E (water availability)</a:t>
+              </a:r>
+              <a:endParaRPr lang="en-US" sz="1000" dirty="0"/>
+            </a:p>
+          </p:txBody>
+        </p:sp>
+      </p:grpSp>
+      <p:sp>
+        <p:nvSpPr>
+          <p:cNvPr id="105" name="Shape 103">
+            <a:extLst>
+              <a:ext uri="{FF2B5EF4-FFF2-40B4-BE49-F238E27FC236}">
+                <a16:creationId xmlns:a16="http://schemas.microsoft.com/office/drawing/2014/main" id="{54169389-9E7D-0BBE-CE7A-68E58A90AA89}"/>
+              </a:ext>
+            </a:extLst>
+          </p:cNvPr>
+          <p:cNvSpPr/>
+          <p:nvPr/>
+        </p:nvSpPr>
+        <p:spPr>
+          <a:xfrm>
+            <a:off x="3895344" y="9105181"/>
+            <a:ext cx="2103120" cy="859536"/>
           </a:xfrm>
           <a:prstGeom prst="roundRect">
             <a:avLst>
@@ -5833,26 +5136,26 @@
           <a:bodyPr/>
           <a:lstStyle/>
           <a:p>
-            <a:endParaRPr lang="en-US" dirty="0"/>
-          </a:p>
-        </p:txBody>
-      </p:sp>
-      <p:sp>
-        <p:nvSpPr>
-          <p:cNvPr id="103" name="Text 101">
-            <a:extLst>
-              <a:ext uri="{FF2B5EF4-FFF2-40B4-BE49-F238E27FC236}">
-                <a16:creationId xmlns:a16="http://schemas.microsoft.com/office/drawing/2014/main" id="{9EF43DF7-5C53-4A9B-7863-196172355C6A}"/>
-              </a:ext>
-            </a:extLst>
-          </p:cNvPr>
-          <p:cNvSpPr/>
-          <p:nvPr/>
-        </p:nvSpPr>
-        <p:spPr>
-          <a:xfrm>
-            <a:off x="1810512" y="9308193"/>
-            <a:ext cx="1567688" cy="164592"/>
+            <a:endParaRPr lang="en-US"/>
+          </a:p>
+        </p:txBody>
+      </p:sp>
+      <p:sp>
+        <p:nvSpPr>
+          <p:cNvPr id="106" name="Text 104">
+            <a:extLst>
+              <a:ext uri="{FF2B5EF4-FFF2-40B4-BE49-F238E27FC236}">
+                <a16:creationId xmlns:a16="http://schemas.microsoft.com/office/drawing/2014/main" id="{11C54DC0-C5BA-8ABE-BFAE-C8DB16FA29DB}"/>
+              </a:ext>
+            </a:extLst>
+          </p:cNvPr>
+          <p:cNvSpPr/>
+          <p:nvPr/>
+        </p:nvSpPr>
+        <p:spPr>
+          <a:xfrm>
+            <a:off x="4124768" y="9209784"/>
+            <a:ext cx="1644270" cy="173739"/>
           </a:xfrm>
           <a:prstGeom prst="rect">
             <a:avLst/>
@@ -5870,7 +5173,7 @@
               <a:buNone/>
             </a:pPr>
             <a:r>
-              <a:rPr lang="en-US" sz="1200" b="1" dirty="0">
+              <a:rPr lang="en-US" sz="1180" b="1" dirty="0">
                 <a:solidFill>
                   <a:srgbClr val="3275A5"/>
                 </a:solidFill>
@@ -5878,28 +5181,28 @@
                 <a:ea typeface="Arial" pitchFamily="34" charset="-122"/>
                 <a:cs typeface="Arial" pitchFamily="34" charset="-120"/>
               </a:rPr>
-              <a:t>Released TWC products</a:t>
+              <a:t>Derived summaries</a:t>
             </a:r>
-            <a:endParaRPr lang="en-US" sz="1200" dirty="0"/>
-          </a:p>
-        </p:txBody>
-      </p:sp>
-      <p:sp>
-        <p:nvSpPr>
-          <p:cNvPr id="104" name="Text 102">
-            <a:extLst>
-              <a:ext uri="{FF2B5EF4-FFF2-40B4-BE49-F238E27FC236}">
-                <a16:creationId xmlns:a16="http://schemas.microsoft.com/office/drawing/2014/main" id="{4A8F015A-C4CF-66B7-7325-50D425A1A7EF}"/>
-              </a:ext>
-            </a:extLst>
-          </p:cNvPr>
-          <p:cNvSpPr/>
-          <p:nvPr/>
-        </p:nvSpPr>
-        <p:spPr>
-          <a:xfrm>
-            <a:off x="1577773" y="9644725"/>
-            <a:ext cx="2180224" cy="274320"/>
+            <a:endParaRPr lang="en-US" sz="1180" dirty="0"/>
+          </a:p>
+        </p:txBody>
+      </p:sp>
+      <p:sp>
+        <p:nvSpPr>
+          <p:cNvPr id="107" name="Text 105">
+            <a:extLst>
+              <a:ext uri="{FF2B5EF4-FFF2-40B4-BE49-F238E27FC236}">
+                <a16:creationId xmlns:a16="http://schemas.microsoft.com/office/drawing/2014/main" id="{ACCD25C6-4C89-A4EC-E903-32571BB8CFE8}"/>
+              </a:ext>
+            </a:extLst>
+          </p:cNvPr>
+          <p:cNvSpPr/>
+          <p:nvPr/>
+        </p:nvSpPr>
+        <p:spPr>
+          <a:xfrm>
+            <a:off x="3924487" y="9512050"/>
+            <a:ext cx="2022789" cy="292608"/>
           </a:xfrm>
           <a:prstGeom prst="rect">
             <a:avLst/>
@@ -5925,7 +5228,7 @@
                 <a:ea typeface="Arial" pitchFamily="34" charset="-122"/>
                 <a:cs typeface="Arial" pitchFamily="34" charset="-120"/>
               </a:rPr>
-              <a:t>P · E · P-E (water availability)</a:t>
+              <a:t>weights - statistics - trends -</a:t>
             </a:r>
             <a:endParaRPr lang="en-US" sz="1000" dirty="0"/>
           </a:p>
@@ -5942,341 +5245,9 @@
                 <a:ea typeface="Arial" pitchFamily="34" charset="-122"/>
                 <a:cs typeface="Arial" pitchFamily="34" charset="-120"/>
               </a:rPr>
-              <a:t>(P+E)/2 (water-cycle flux)</a:t>
+              <a:t>uncertainty - geospatial masks</a:t>
             </a:r>
             <a:endParaRPr lang="en-US" sz="1000" dirty="0"/>
-          </a:p>
-        </p:txBody>
-      </p:sp>
-      <p:sp>
-        <p:nvSpPr>
-          <p:cNvPr id="105" name="Shape 103">
-            <a:extLst>
-              <a:ext uri="{FF2B5EF4-FFF2-40B4-BE49-F238E27FC236}">
-                <a16:creationId xmlns:a16="http://schemas.microsoft.com/office/drawing/2014/main" id="{54169389-9E7D-0BBE-CE7A-68E58A90AA89}"/>
-              </a:ext>
-            </a:extLst>
-          </p:cNvPr>
-          <p:cNvSpPr/>
-          <p:nvPr/>
-        </p:nvSpPr>
-        <p:spPr>
-          <a:xfrm>
-            <a:off x="3895344" y="9217152"/>
-            <a:ext cx="2103120" cy="859536"/>
-          </a:xfrm>
-          <a:prstGeom prst="roundRect">
-            <a:avLst>
-              <a:gd name="adj" fmla="val 11765"/>
-            </a:avLst>
-          </a:prstGeom>
-          <a:solidFill>
-            <a:srgbClr val="FFFFFF"/>
-          </a:solidFill>
-          <a:ln w="13335">
-            <a:solidFill>
-              <a:srgbClr val="3275A5"/>
-            </a:solidFill>
-            <a:prstDash val="solid"/>
-          </a:ln>
-        </p:spPr>
-        <p:txBody>
-          <a:bodyPr/>
-          <a:lstStyle/>
-          <a:p>
-            <a:endParaRPr lang="en-US"/>
-          </a:p>
-        </p:txBody>
-      </p:sp>
-      <p:sp>
-        <p:nvSpPr>
-          <p:cNvPr id="106" name="Text 104">
-            <a:extLst>
-              <a:ext uri="{FF2B5EF4-FFF2-40B4-BE49-F238E27FC236}">
-                <a16:creationId xmlns:a16="http://schemas.microsoft.com/office/drawing/2014/main" id="{11C54DC0-C5BA-8ABE-BFAE-C8DB16FA29DB}"/>
-              </a:ext>
-            </a:extLst>
-          </p:cNvPr>
-          <p:cNvSpPr/>
-          <p:nvPr/>
-        </p:nvSpPr>
-        <p:spPr>
-          <a:xfrm>
-            <a:off x="4145534" y="9297377"/>
-            <a:ext cx="1644270" cy="173739"/>
-          </a:xfrm>
-          <a:prstGeom prst="rect">
-            <a:avLst/>
-          </a:prstGeom>
-          <a:noFill/>
-          <a:ln/>
-        </p:spPr>
-        <p:txBody>
-          <a:bodyPr wrap="square" lIns="0" tIns="0" rIns="0" bIns="0" rtlCol="0" anchor="ctr">
-            <a:noAutofit/>
-          </a:bodyPr>
-          <a:lstStyle/>
-          <a:p>
-            <a:pPr marL="0" indent="0" algn="ctr">
-              <a:buNone/>
-            </a:pPr>
-            <a:r>
-              <a:rPr lang="en-US" sz="1180" b="1" dirty="0">
-                <a:solidFill>
-                  <a:srgbClr val="3275A5"/>
-                </a:solidFill>
-                <a:latin typeface="Arial" pitchFamily="34" charset="0"/>
-                <a:ea typeface="Arial" pitchFamily="34" charset="-122"/>
-                <a:cs typeface="Arial" pitchFamily="34" charset="-120"/>
-              </a:rPr>
-              <a:t>Derived summaries and labels</a:t>
-            </a:r>
-            <a:endParaRPr lang="en-US" sz="1180" dirty="0"/>
-          </a:p>
-        </p:txBody>
-      </p:sp>
-      <p:sp>
-        <p:nvSpPr>
-          <p:cNvPr id="107" name="Text 105">
-            <a:extLst>
-              <a:ext uri="{FF2B5EF4-FFF2-40B4-BE49-F238E27FC236}">
-                <a16:creationId xmlns:a16="http://schemas.microsoft.com/office/drawing/2014/main" id="{ACCD25C6-4C89-A4EC-E903-32571BB8CFE8}"/>
-              </a:ext>
-            </a:extLst>
-          </p:cNvPr>
-          <p:cNvSpPr/>
-          <p:nvPr/>
-        </p:nvSpPr>
-        <p:spPr>
-          <a:xfrm>
-            <a:off x="3924487" y="9624021"/>
-            <a:ext cx="2022789" cy="292608"/>
-          </a:xfrm>
-          <a:prstGeom prst="rect">
-            <a:avLst/>
-          </a:prstGeom>
-          <a:noFill/>
-          <a:ln/>
-        </p:spPr>
-        <p:txBody>
-          <a:bodyPr wrap="square" lIns="0" tIns="0" rIns="0" bIns="0" rtlCol="0" anchor="ctr">
-            <a:noAutofit/>
-          </a:bodyPr>
-          <a:lstStyle/>
-          <a:p>
-            <a:pPr marL="0" indent="0" algn="ctr">
-              <a:buNone/>
-            </a:pPr>
-            <a:r>
-              <a:rPr lang="en-US" sz="1000" dirty="0">
-                <a:solidFill>
-                  <a:srgbClr val="25322D"/>
-                </a:solidFill>
-                <a:latin typeface="Arial" pitchFamily="34" charset="0"/>
-                <a:ea typeface="Arial" pitchFamily="34" charset="-122"/>
-                <a:cs typeface="Arial" pitchFamily="34" charset="-120"/>
-              </a:rPr>
-              <a:t>period contrasts · trends</a:t>
-            </a:r>
-            <a:endParaRPr lang="en-US" sz="1000" dirty="0"/>
-          </a:p>
-          <a:p>
-            <a:pPr marL="0" indent="0" algn="ctr">
-              <a:buNone/>
-            </a:pPr>
-            <a:r>
-              <a:rPr lang="en-US" sz="1000" dirty="0">
-                <a:solidFill>
-                  <a:srgbClr val="25322D"/>
-                </a:solidFill>
-                <a:latin typeface="Arial" pitchFamily="34" charset="0"/>
-                <a:ea typeface="Arial" pitchFamily="34" charset="-122"/>
-                <a:cs typeface="Arial" pitchFamily="34" charset="-120"/>
-              </a:rPr>
-              <a:t>uncertainty summaries · global storyline labels</a:t>
-            </a:r>
-            <a:endParaRPr lang="en-US" sz="1000" dirty="0"/>
-          </a:p>
-        </p:txBody>
-      </p:sp>
-      <p:sp>
-        <p:nvSpPr>
-          <p:cNvPr id="108" name="Text 106">
-            <a:extLst>
-              <a:ext uri="{FF2B5EF4-FFF2-40B4-BE49-F238E27FC236}">
-                <a16:creationId xmlns:a16="http://schemas.microsoft.com/office/drawing/2014/main" id="{0097B555-1968-7476-4D7F-0D31915FA988}"/>
-              </a:ext>
-            </a:extLst>
-          </p:cNvPr>
-          <p:cNvSpPr/>
-          <p:nvPr/>
-        </p:nvSpPr>
-        <p:spPr>
-          <a:xfrm>
-            <a:off x="1688083" y="8889668"/>
-            <a:ext cx="4343908" cy="182880"/>
-          </a:xfrm>
-          <a:prstGeom prst="rect">
-            <a:avLst/>
-          </a:prstGeom>
-          <a:noFill/>
-          <a:ln/>
-        </p:spPr>
-        <p:txBody>
-          <a:bodyPr wrap="square" lIns="0" tIns="0" rIns="0" bIns="0" rtlCol="0" anchor="ctr">
-            <a:normAutofit/>
-          </a:bodyPr>
-          <a:lstStyle/>
-          <a:p>
-            <a:pPr marL="0" indent="0" algn="ctr">
-              <a:buNone/>
-            </a:pPr>
-            <a:r>
-              <a:rPr lang="en-US" sz="1100" b="1" dirty="0">
-                <a:solidFill>
-                  <a:srgbClr val="3275A5"/>
-                </a:solidFill>
-                <a:latin typeface="Arial" pitchFamily="34" charset="0"/>
-                <a:ea typeface="Arial" pitchFamily="34" charset="-122"/>
-                <a:cs typeface="Arial" pitchFamily="34" charset="-120"/>
-              </a:rPr>
-              <a:t>Supported scales: grid · region x biome · IPCC region · global</a:t>
-            </a:r>
-            <a:endParaRPr lang="en-US" sz="1100" dirty="0"/>
-          </a:p>
-        </p:txBody>
-      </p:sp>
-      <p:sp>
-        <p:nvSpPr>
-          <p:cNvPr id="109" name="Shape 107">
-            <a:extLst>
-              <a:ext uri="{FF2B5EF4-FFF2-40B4-BE49-F238E27FC236}">
-                <a16:creationId xmlns:a16="http://schemas.microsoft.com/office/drawing/2014/main" id="{F3EC2E90-E635-2569-BF7A-BAD3252521F7}"/>
-              </a:ext>
-            </a:extLst>
-          </p:cNvPr>
-          <p:cNvSpPr/>
-          <p:nvPr/>
-        </p:nvSpPr>
-        <p:spPr>
-          <a:xfrm>
-            <a:off x="6254496" y="9167731"/>
-            <a:ext cx="1170432" cy="640080"/>
-          </a:xfrm>
-          <a:prstGeom prst="roundRect">
-            <a:avLst>
-              <a:gd name="adj" fmla="val 9756"/>
-            </a:avLst>
-          </a:prstGeom>
-          <a:solidFill>
-            <a:srgbClr val="F6F6F0"/>
-          </a:solidFill>
-          <a:ln w="12700">
-            <a:solidFill>
-              <a:srgbClr val="B8B3A4"/>
-            </a:solidFill>
-            <a:prstDash val="solid"/>
-          </a:ln>
-        </p:spPr>
-        <p:txBody>
-          <a:bodyPr/>
-          <a:lstStyle/>
-          <a:p>
-            <a:endParaRPr lang="en-US" sz="2400"/>
-          </a:p>
-        </p:txBody>
-      </p:sp>
-      <p:sp>
-        <p:nvSpPr>
-          <p:cNvPr id="111" name="Text 109">
-            <a:extLst>
-              <a:ext uri="{FF2B5EF4-FFF2-40B4-BE49-F238E27FC236}">
-                <a16:creationId xmlns:a16="http://schemas.microsoft.com/office/drawing/2014/main" id="{F9BD7362-6FBE-8592-8CCF-7367BA4AA076}"/>
-              </a:ext>
-            </a:extLst>
-          </p:cNvPr>
-          <p:cNvSpPr/>
-          <p:nvPr/>
-        </p:nvSpPr>
-        <p:spPr>
-          <a:xfrm>
-            <a:off x="6385052" y="9243931"/>
-            <a:ext cx="1157798" cy="164592"/>
-          </a:xfrm>
-          <a:prstGeom prst="rect">
-            <a:avLst/>
-          </a:prstGeom>
-          <a:noFill/>
-          <a:ln/>
-        </p:spPr>
-        <p:txBody>
-          <a:bodyPr wrap="square" lIns="0" tIns="0" rIns="0" bIns="0" rtlCol="0" anchor="ctr">
-            <a:noAutofit/>
-          </a:bodyPr>
-          <a:lstStyle/>
-          <a:p>
-            <a:pPr marL="0" indent="0">
-              <a:buNone/>
-            </a:pPr>
-            <a:r>
-              <a:rPr lang="en-US" sz="1050" b="1" dirty="0">
-                <a:solidFill>
-                  <a:srgbClr val="25322D"/>
-                </a:solidFill>
-                <a:latin typeface="Arial" pitchFamily="34" charset="0"/>
-                <a:ea typeface="Arial" pitchFamily="34" charset="-122"/>
-                <a:cs typeface="Arial" pitchFamily="34" charset="-120"/>
-              </a:rPr>
-              <a:t>Final data</a:t>
-            </a:r>
-            <a:endParaRPr lang="en-US" sz="1050" dirty="0"/>
-          </a:p>
-        </p:txBody>
-      </p:sp>
-      <p:sp>
-        <p:nvSpPr>
-          <p:cNvPr id="112" name="Text 110">
-            <a:extLst>
-              <a:ext uri="{FF2B5EF4-FFF2-40B4-BE49-F238E27FC236}">
-                <a16:creationId xmlns:a16="http://schemas.microsoft.com/office/drawing/2014/main" id="{59E888F0-47FF-D714-6ED4-BD834E0E45E5}"/>
-              </a:ext>
-            </a:extLst>
-          </p:cNvPr>
-          <p:cNvSpPr/>
-          <p:nvPr/>
-        </p:nvSpPr>
-        <p:spPr>
-          <a:xfrm>
-            <a:off x="6285992" y="9465271"/>
-            <a:ext cx="1145540" cy="284903"/>
-          </a:xfrm>
-          <a:prstGeom prst="rect">
-            <a:avLst/>
-          </a:prstGeom>
-          <a:noFill/>
-          <a:ln/>
-        </p:spPr>
-        <p:txBody>
-          <a:bodyPr wrap="square" lIns="0" tIns="0" rIns="0" bIns="0" rtlCol="0" anchor="ctr">
-            <a:noAutofit/>
-          </a:bodyPr>
-          <a:lstStyle/>
-          <a:p>
-            <a:pPr marL="0" indent="0">
-              <a:buNone/>
-            </a:pPr>
-            <a:r>
-              <a:rPr lang="en-US" sz="900" dirty="0">
-                <a:solidFill>
-                  <a:srgbClr val="667269"/>
-                </a:solidFill>
-                <a:latin typeface="Arial" pitchFamily="34" charset="0"/>
-                <a:ea typeface="Arial" pitchFamily="34" charset="-122"/>
-                <a:cs typeface="Arial" pitchFamily="34" charset="-120"/>
-              </a:rPr>
-              <a:t>Products, summaries, and provenance</a:t>
-            </a:r>
-            <a:endParaRPr lang="en-US" sz="900" dirty="0"/>
           </a:p>
         </p:txBody>
       </p:sp>

</xml_diff>